<commit_message>
Present LISRec first and add Chinese paper explanations
- Reorder the deck so LISRec is Paper A (slides 3-6) and the stage-wise
  news recommendation paper is Paper B (slides 7-10); swap A/B labels,
  figure prefixes, comparison table columns and references
- Rewrite 講稿.md in the new order with updated running times
- Add LISRec_詳解.pdf and StageWise新聞推薦_詳解.pdf
- Update README to match

Co-Authored-By: Claude Opus 5.5 <noreply@anthropic.com>
</commit_message>
<xml_diff>
--- a/paper_presentation.pptx
+++ b/paper_presentation.pptx
@@ -520,7 +520,7 @@
           <a:p/>
           <a:p>
             <a:r>
-              <a:t>大家好，今天我們要報告的是兩篇 2026 年推薦系統領域的論文。第一篇是發表在 WWW 2026 的「Modeling Stage-wise Evolution of User Interests for News Recommendation」，我們簡稱 Paper A；第二篇是 KDD 2026 的 LISRec，簡稱 Paper B。這兩篇論文其實都在回答同一個問題：使用者的點擊紀錄，到底能多準確地反映他真正的喜好？</a:t>
+              <a:t>大家好，今天我們要報告的是兩篇 2026 年推薦系統領域的論文。第一篇是發表在 KDD 2026 的 LISRec，我們簡稱 Paper A；第二篇是 WWW 2026 的「Modeling Stage-wise Evolution of User Interests for News Recommendation」，簡稱 Paper B。這兩篇論文其實都在回答同一個問題：使用者的點擊紀錄，到底能多準確地反映他真正的喜好？</a:t>
             </a:r>
           </a:p>
         </p:txBody>
@@ -596,25 +596,19 @@
           <a:p/>
           <a:p>
             <a:r>
-              <a:t>實驗用四個資料集：Amazon 的 Beauty、Sports、Toys，以及 Yelp。上面的 Table 1 裡，LISRec 以 TASTE 為基底，跟十一個 ID-based 和 text-based 的模型比較，幾乎在所有指標上都是最好的，最多進步約 13%。</a:t>
+              <a:t>看結果。上面是 Table 2，這個方法在兩個資料集的所有指標都是最好的。在 Adressa 上 AUC 達到 0.80，第二名的 CROWN 只有 0.66，差距很大；在 MIND 上是 0.58 對 0.55，進步幅度就比較小。</a:t>
             </a:r>
           </a:p>
           <a:p/>
           <a:p>
             <a:r>
-              <a:t>進步幅度在購物資料集最明顯，在 Yelp 上比較小。作者的解釋是購物情境裡，使用者更常因一時興趣而隨手點擊。</a:t>
+              <a:t>左下是消融實驗。不管拿掉整個 LPM、只拿掉 LSTM 分支、只拿掉 attention 分支，或拿掉全域的 GPM，表現都明顯下降，表示這三個部分是互補的。</a:t>
             </a:r>
           </a:p>
           <a:p/>
           <a:p>
             <a:r>
-              <a:t>另外，跟專門去雜訊的方法 DSAN、HSD、DCRec 比，在相同的 BERT4Rec 基底下，LISRec 平均好了約 4.7%。消融實驗也顯示，就算是沒訓練過的 zero-shot 過濾器都有幫助。</a:t>
-            </a:r>
-          </a:p>
-          <a:p/>
-          <a:p>
-            <a:r>
-              <a:t>左下是門檻 τ 的敏感度分析：τ 太低會讓雜訊混進來，中等的 τ 效果最好，而且每一個 τ 都比完全不過濾好。右下的 Figure 6 顯示，用捷徑訓練後，使用者表示跟目標物品更接近，被移除的物品在 embedding 空間裡也被推到外圍。</a:t>
+              <a:t>右下是時間窗大小的實驗，比較一到四週。兩週表現最好：窗太短，每個子圖資料太稀疏；窗太長，又會把細微的興趣變化抹平。</a:t>
             </a:r>
           </a:p>
         </p:txBody>
@@ -690,13 +684,13 @@
           <a:p/>
           <a:p>
             <a:r>
-              <a:t>把兩篇放在一起比較。Paper A 挑戰的是「歷史是靜態的」，Paper B 挑戰的是「歷史是乾淨的」。A 主要用時間戳記加上協同圖，B 用的是物品文字語意。A 的圖是全域加上各時段的使用者–新聞圖，B 的圖則是每個使用者自己的物品相似度圖。資料方面，A 是新聞，B 是電商和地點評論。最後一個差別是，A 是一個完整的端到端模型，B 則是可以接在任何推薦模型前面的過濾器。</a:t>
+              <a:t>把兩篇放在一起比較。Paper A 挑戰的是「歷史是乾淨的」，Paper B 挑戰的是「歷史是靜態的」。A 用的是物品文字語意，B 主要用時間戳記加上協同圖。A 的圖是每個使用者自己的物品相似度圖，B 的圖則是全域加上各時段的使用者–新聞圖。資料方面，A 是電商和地點評論，B 是新聞。最後一個差別是，A 是可以接在任何推薦模型前面的過濾器，B 則是一個完整的端到端模型。</a:t>
             </a:r>
           </a:p>
           <a:p/>
           <a:p>
             <a:r>
-              <a:t>簡單說，A 回答的是「某個興趣什麼時候重要」，B 回答的是「哪些紀錄真的代表這個使用者」。</a:t>
+              <a:t>簡單說，A 回答的是「哪些紀錄真的代表這個使用者」，B 回答的是「某個興趣什麼時候重要」。</a:t>
             </a:r>
           </a:p>
         </p:txBody>
@@ -772,19 +766,19 @@
           <a:p/>
           <a:p>
             <a:r>
-              <a:t>總結一下。Paper A 依照時間切開歷史，用全域圖抓穩定喜好，再用時段子圖加 LSTM 和 attention 抓興趣變化。Paper B 依照語意切開歷史，只保留語意一致的核心物品。兩篇的共同點是：不直接把原始紀錄丟進模型，而是先重新整理歷史。</a:t>
+              <a:t>總結一下。Paper A 依照語意篩選歷史，只保留語意一致的核心物品。Paper B 依照時間切開歷史，用全域圖抓穩定喜好，再用時段子圖加 LSTM 和 attention 抓興趣變化。兩篇的共同點是：不直接把原始紀錄丟進模型，而是先重新整理歷史。</a:t>
             </a:r>
           </a:p>
           <a:p/>
           <a:p>
             <a:r>
-              <a:t>我們也有幾個想跟大家討論的問題。第一，Paper A 在 Adressa 上有好幾個 baseline 的 AUC 大約 0.5，接近隨機，比較基準是否公平值得思考。第二，MIND 沒有真正的時間戳記，只能平分成假的時段。第三，Paper B 只取最大連通分量，那如果使用者本來就有好幾個真正的興趣，會不會把次要但真實的興趣也濾掉？最後，這兩篇其實可以結合：先用 B 去掉雜訊，再用 A 建模興趣隨時間的變化。</a:t>
+              <a:t>我們也有幾個想跟大家討論的問題。第一，Paper A 只取最大連通分量，那如果使用者本來就有好幾個真正的興趣，會不會把次要但真實的興趣也濾掉？第二，Paper B 在 Adressa 上有好幾個 baseline 的 AUC 大約 0.5，接近隨機，比較基準是否公平值得思考。第三，MIND 沒有真正的時間戳記，只能平分成假的時段。最後，這兩篇其實可以結合：先用 A 去掉雜訊，再用 B 建模興趣隨時間的變化。</a:t>
             </a:r>
           </a:p>
           <a:p/>
           <a:p>
             <a:r>
-              <a:t>一句話總結：更好的推薦，來自更好地理解歷史紀錄，也就是知道興趣什麼時候重要，以及哪些點擊真的算數。</a:t>
+              <a:t>一句話總結：更好的推薦，來自更好地理解歷史紀錄，也就是知道哪些點擊真的算數，以及興趣什麼時候重要。</a:t>
             </a:r>
           </a:p>
         </p:txBody>
@@ -942,13 +936,13 @@
           <a:p/>
           <a:p>
             <a:r>
-              <a:t>第一，它們用的是同一種原始資料，也就是大量的使用者互動紀錄。像 Paper A 用的 Adressa 資料集就有三千五百萬筆點擊，這正是巨量資料分析在推薦系統裡最典型的應用場景。</a:t>
+              <a:t>第一，它們用的是同一種原始資料，也就是大量的使用者互動紀錄。像 Paper B 用的 Adressa 資料集就有三千五百萬筆點擊，這正是巨量資料分析在推薦系統裡最典型的應用場景。</a:t>
             </a:r>
           </a:p>
           <a:p/>
           <a:p>
             <a:r>
-              <a:t>第二，大部分推薦模型都有一個隱含的假設：使用者的歷史紀錄是乾淨而且靜態的。這兩篇論文剛好各自挑戰了其中一半。Paper A 認為歷史「不是靜態的」，使用者興趣會隨時間改變；Paper B 認為歷史「不是乾淨的」，裡面有很多隨手亂點的雜訊。</a:t>
+              <a:t>第二，大部分推薦模型都有一個隱含的假設：使用者的歷史紀錄是乾淨而且靜態的。這兩篇論文剛好各自挑戰了其中一半。Paper A 認為歷史「不是乾淨的」，裡面有很多隨手亂點的雜訊；Paper B 認為歷史「不是靜態的」，使用者興趣會隨時間改變。</a:t>
             </a:r>
           </a:p>
           <a:p/>
@@ -960,7 +954,7 @@
           <a:p/>
           <a:p>
             <a:r>
-              <a:t>所以下面這兩個框框就是今天的主軸：Paper A 從「時間」切入，把歷史切成不同階段；Paper B 從「語意」切入，只留下彼此一致的物品、把離群的點擊丟掉。</a:t>
+              <a:t>所以下面這兩個框框就是今天的主軸：Paper A 從「語意」切入，只留下彼此一致的物品、把離群的點擊丟掉；Paper B 從「時間」切入，把歷史切成不同階段。</a:t>
             </a:r>
           </a:p>
         </p:txBody>
@@ -1030,25 +1024,25 @@
           <a:lstStyle/>
           <a:p>
             <a:r>
-              <a:t>Paper A：新聞興趣具有時效性（1:00，累計 3:00）</a:t>
+              <a:t>Paper A：不是每次點擊都代表喜好（1:00，累計 3:00）</a:t>
             </a:r>
           </a:p>
           <a:p/>
           <a:p>
             <a:r>
-              <a:t>先看 Paper A。新聞推薦跟電商最大的不同是時效性：新聞很快就過時，大家想看的是最新的事件。使用者的興趣也分兩種，一種是長期穩定的閱讀習慣，例如一直在看財經新聞；另一種是被事件帶動的短期興趣，像世界盃期間突然狂看體育新聞，疫情期間健康新聞暴增。</a:t>
+              <a:t>先看 Paper A，LISRec，它處理的是雜訊問題。看左邊論文的 Figure 1：一個使用者一直買 LEGO，鋼鐵人、Stitch、Bugatti、星際大戰，但中間點了一次 Nintendo Switch 的瑪利歐賽車，可能只是一時好奇。</a:t>
             </a:r>
           </a:p>
           <a:p/>
           <a:p>
             <a:r>
-              <a:t>現有方法大致在兩個極端。右邊第一種是靜態圖模型，把所有時間的點擊放在同一張圖裡，三個月前的興趣跟昨天的一樣重要，推薦就容易過時。第二種是純序列模型，只盯著最近的點擊，容易被短暫熱點牽著走，也失去了整張圖的協同訊號。</a:t>
+              <a:t>不論是用物品 ID 的模型，像 SASRec、BERT4Rec，或是用文字的模型，像 TASTE、HLLM，通常都把每一筆紀錄一視同仁，雜訊就會被帶進使用者表示裡。過去的去雜訊方法多半是調整權重或用隱式的對比學習，沒有明確把雜訊拿掉，也比較難解釋。</a:t>
             </a:r>
           </a:p>
           <a:p/>
           <a:p>
             <a:r>
-              <a:t>作者的關鍵觀察是：同一段時間內的點擊通常是一致的，而跨時段的變化就代表興趣的演變。</a:t>
+              <a:t>LISRec 的想法是找出一條語意上的「捷徑」，也就是歷史裡彼此一致的那一群物品，只用它們來代表使用者。</a:t>
             </a:r>
           </a:p>
         </p:txBody>
@@ -1118,43 +1112,37 @@
           <a:lstStyle/>
           <a:p>
             <a:r>
-              <a:t>Paper A：模型架構（1:45，累計 4:45）</a:t>
+              <a:t>Paper A：LISRec 流程（1:30，累計 4:30）</a:t>
             </a:r>
           </a:p>
           <a:p/>
           <a:p>
             <a:r>
-              <a:t>這張是論文的 Figure 1，我們由左到右來看。</a:t>
+              <a:t>這是 LISRec 的架構圖，可以拆成三個步驟。</a:t>
             </a:r>
           </a:p>
           <a:p/>
           <a:p>
             <a:r>
-              <a:t>最左邊是 Global Preference Modeling，簡稱 GPM。它在完整的使用者–新聞互動圖上跑 LightGCN，學到每個使用者和新聞的長期 embedding。這個全域 embedding 還有第二個用途：拿來初始化後面每個時段的子圖，因為單一時段的資料很稀疏，好的初始化很重要。</a:t>
+              <a:t>第一步，訓練一個與任務無關的物品編碼器。作者用 T5，只用物品的文字描述、不用 ID，用「根據瀏覽紀錄推薦下一個物品」的指令格式，在多個資料集上一起訓練。這樣學到的相似度會跟使用者喜好有關，也比較能跨領域使用。</a:t>
             </a:r>
           </a:p>
           <a:p/>
           <a:p>
             <a:r>
-              <a:t>中間是 Local Preference Modeling，簡稱 LPM。作者先把點擊依時間切成 T 個區間，例如每兩週一段，每一段建一張時序子圖 G1 到 GT。LPM 裡有兩個分支：</a:t>
+              <a:t>第二步，對每個使用者建一張個人化的物品圖。節點是他點過的所有物品，兩個物品的 cosine 相似度大於門檻 τ 就連一條邊，論文設定 τ 等於 0.7。</a:t>
             </a:r>
           </a:p>
           <a:p/>
           <a:p>
             <a:r>
-              <a:t>上面是短期演化分支，在每張子圖上各跑一次 GCN，再用 LSTM 把相鄰時段串起來，捕捉興趣一步步的變化，對最近的行為比較敏感。</a:t>
+              <a:t>第三步，取這張圖裡最大的連通分量，當作捷徑。只有這些物品會被拿去訓練和推論推薦模型，其他的就當作雜訊排除。</a:t>
             </a:r>
           </a:p>
           <a:p/>
           <a:p>
             <a:r>
-              <a:t>下面是長距離聚合分支，用 self-attention 看到目前為止所有點擊，再加上位置編碼，讓模型知道哪些點擊比較早、哪些比較新，補足 LSTM 只看相鄰時段的不足。</a:t>
-            </a:r>
-          </a:p>
-          <a:p/>
-          <a:p>
-            <a:r>
-              <a:t>最右邊是融合：使用者表示等於短期、長距離、全域三個 embedding 相加，再跟新聞的 embedding 做內積，經過 sigmoid 得到點擊機率。</a:t>
+              <a:t>這個設計的好處是它像一個前處理的過濾器，可以接在不同的推薦模型前面，文字模型 TASTE 和 ID 模型 BERT4Rec 都能用。</a:t>
             </a:r>
           </a:p>
         </p:txBody>
@@ -1224,37 +1212,25 @@
           <a:lstStyle/>
           <a:p>
             <a:r>
-              <a:t>Paper A：訓練目標（1:00，累計 5:45）</a:t>
+              <a:t>Paper A：案例分析（1:00，累計 5:30）</a:t>
             </a:r>
           </a:p>
           <a:p/>
           <a:p>
             <a:r>
-              <a:t>訓練目標由三個部分組成。</a:t>
+              <a:t>這是論文 Table 5 的實際例子，來自 Amazon Beauty。這個使用者點過四個商品，其中 n1、n2、n4 都是保濕乳液，彼此相似度大約 0.44 到 0.46；n3 是一瓶 Valentino 香水，跟其他商品的相似度只有 0.20 到 0.25。</a:t>
             </a:r>
           </a:p>
           <a:p/>
           <a:p>
             <a:r>
-              <a:t>第一是預測損失，在每個時段內用 binary cross-entropy，每個正樣本搭配四個負樣本。</a:t>
+              <a:t>所以建圖之後，邊只出現在 1、2、4 之間，香水是孤立的，最後留下來的捷徑就是 {1, 2, 4}。Yelp 的例子也一樣，一個常去酒吧和餐廳的使用者去過一次動物醫院，那筆紀錄就被濾掉了。</a:t>
             </a:r>
           </a:p>
           <a:p/>
           <a:p>
             <a:r>
-              <a:t>第二是一致性正則化，用對比學習讓同一個使用者在某個時段的 embedding 靠近他自己的全域 embedding，並遠離其他使用者，避免時序表示偏離太多。</a:t>
-            </a:r>
-          </a:p>
-          <a:p/>
-          <a:p>
-            <a:r>
-              <a:t>第三是平滑正則化，讓相鄰時段的 embedding 不要差太多，因為興趣通常是漸進改變，不會突然跳很遠。</a:t>
-            </a:r>
-          </a:p>
-          <a:p/>
-          <a:p>
-            <a:r>
-              <a:t>實驗用的是兩個大型新聞資料集：Adressa 有三百六十萬使用者、三千五百萬筆點擊，橫跨三個月；MIND 有一百萬使用者、兩千四百萬筆點擊。評估指標是 AUC、MRR 和 nDCG，跟七個 baseline 比較。</a:t>
+              <a:t>這種做法最大的優點是可解釋：我們可以清楚看到哪些點擊被移除、為什麼被移除。</a:t>
             </a:r>
           </a:p>
         </p:txBody>
@@ -1324,25 +1300,31 @@
           <a:lstStyle/>
           <a:p>
             <a:r>
-              <a:t>Paper A：實驗結果（1:30，累計 7:15）</a:t>
+              <a:t>Paper A：實驗結果（1:30，累計 7:00）</a:t>
             </a:r>
           </a:p>
           <a:p/>
           <a:p>
             <a:r>
-              <a:t>看結果。上面是 Table 2，這個方法在兩個資料集的所有指標都是最好的。在 Adressa 上 AUC 達到 0.80，第二名的 CROWN 只有 0.66，差距很大；在 MIND 上是 0.58 對 0.55，進步幅度就比較小。</a:t>
+              <a:t>實驗用四個資料集：Amazon 的 Beauty、Sports、Toys，以及 Yelp。上面的 Table 1 裡，LISRec 以 TASTE 為基底，跟十一個 ID-based 和 text-based 的模型比較，幾乎在所有指標上都是最好的，最多進步約 13%。</a:t>
             </a:r>
           </a:p>
           <a:p/>
           <a:p>
             <a:r>
-              <a:t>左下是消融實驗。不管拿掉整個 LPM、只拿掉 LSTM 分支、只拿掉 attention 分支，或拿掉全域的 GPM，表現都明顯下降，表示這三個部分是互補的。</a:t>
+              <a:t>進步幅度在購物資料集最明顯，在 Yelp 上比較小。作者的解釋是購物情境裡，使用者更常因一時興趣而隨手點擊。</a:t>
             </a:r>
           </a:p>
           <a:p/>
           <a:p>
             <a:r>
-              <a:t>右下是時間窗大小的實驗，比較一到四週。兩週表現最好：窗太短，每個子圖資料太稀疏；窗太長，又會把細微的興趣變化抹平。</a:t>
+              <a:t>另外，跟專門去雜訊的方法 DSAN、HSD、DCRec 比，在相同的 BERT4Rec 基底下，LISRec 平均好了約 4.7%。消融實驗也顯示，就算是沒訓練過的 zero-shot 過濾器都有幫助。</a:t>
+            </a:r>
+          </a:p>
+          <a:p/>
+          <a:p>
+            <a:r>
+              <a:t>左下是門檻 τ 的敏感度分析：τ 太低會讓雜訊混進來，中等的 τ 效果最好，而且每一個 τ 都比完全不過濾好。右下的 Figure 6 顯示，用捷徑訓練後，使用者表示跟目標物品更接近，被移除的物品在 embedding 空間裡也被推到外圍。</a:t>
             </a:r>
           </a:p>
           <a:p/>
@@ -1418,25 +1400,25 @@
           <a:lstStyle/>
           <a:p>
             <a:r>
-              <a:t>Paper B：不是每次點擊都代表喜好（1:00，累計 8:15）</a:t>
+              <a:t>Paper B：新聞興趣具有時效性（1:00，累計 8:00）</a:t>
             </a:r>
           </a:p>
           <a:p/>
           <a:p>
             <a:r>
-              <a:t>Paper B，LISRec，處理的是雜訊問題。看左邊論文的 Figure 1：一個使用者一直買 LEGO，鋼鐵人、Stitch、Bugatti、星際大戰，但中間點了一次 Nintendo Switch 的瑪利歐賽車，可能只是一時好奇。</a:t>
+              <a:t>接下來看 Paper B。新聞推薦跟電商最大的不同是時效性：新聞很快就過時，大家想看的是最新的事件。使用者的興趣也分兩種，一種是長期穩定的閱讀習慣，例如一直在看財經新聞；另一種是被事件帶動的短期興趣，像世界盃期間突然狂看體育新聞，疫情期間健康新聞暴增。</a:t>
             </a:r>
           </a:p>
           <a:p/>
           <a:p>
             <a:r>
-              <a:t>不論是用物品 ID 的模型，像 SASRec、BERT4Rec，或是用文字的模型，像 TASTE、HLLM，通常都把每一筆紀錄一視同仁，雜訊就會被帶進使用者表示裡。過去的去雜訊方法多半是調整權重或用隱式的對比學習，沒有明確把雜訊拿掉，也比較難解釋。</a:t>
+              <a:t>現有方法大致在兩個極端。右邊第一種是靜態圖模型，把所有時間的點擊放在同一張圖裡，三個月前的興趣跟昨天的一樣重要，推薦就容易過時。第二種是純序列模型，只盯著最近的點擊，容易被短暫熱點牽著走，也失去了整張圖的協同訊號。</a:t>
             </a:r>
           </a:p>
           <a:p/>
           <a:p>
             <a:r>
-              <a:t>LISRec 的想法是找出一條語意上的「捷徑」，也就是歷史裡彼此一致的那一群物品，只用它們來代表使用者。</a:t>
+              <a:t>作者的關鍵觀察是：同一段時間內的點擊通常是一致的，而跨時段的變化就代表興趣的演變。</a:t>
             </a:r>
           </a:p>
         </p:txBody>
@@ -1506,37 +1488,43 @@
           <a:lstStyle/>
           <a:p>
             <a:r>
-              <a:t>Paper B：LISRec 流程（1:30，累計 9:45）</a:t>
+              <a:t>Paper B：模型架構（1:45，累計 9:45）</a:t>
             </a:r>
           </a:p>
           <a:p/>
           <a:p>
             <a:r>
-              <a:t>這是 LISRec 的架構圖，可以拆成三個步驟。</a:t>
+              <a:t>這張是論文的 Figure 1，我們由左到右來看。</a:t>
             </a:r>
           </a:p>
           <a:p/>
           <a:p>
             <a:r>
-              <a:t>第一步，訓練一個與任務無關的物品編碼器。作者用 T5，只用物品的文字描述、不用 ID，用「根據瀏覽紀錄推薦下一個物品」的指令格式，在多個資料集上一起訓練。這樣學到的相似度會跟使用者喜好有關，也比較能跨領域使用。</a:t>
+              <a:t>最左邊是 Global Preference Modeling，簡稱 GPM。它在完整的使用者–新聞互動圖上跑 LightGCN，學到每個使用者和新聞的長期 embedding。這個全域 embedding 還有第二個用途：拿來初始化後面每個時段的子圖，因為單一時段的資料很稀疏，好的初始化很重要。</a:t>
             </a:r>
           </a:p>
           <a:p/>
           <a:p>
             <a:r>
-              <a:t>第二步，對每個使用者建一張個人化的物品圖。節點是他點過的所有物品，兩個物品的 cosine 相似度大於門檻 τ 就連一條邊，論文設定 τ 等於 0.7。</a:t>
+              <a:t>中間是 Local Preference Modeling，簡稱 LPM。作者先把點擊依時間切成 T 個區間，例如每兩週一段，每一段建一張時序子圖 G1 到 GT。LPM 裡有兩個分支：</a:t>
             </a:r>
           </a:p>
           <a:p/>
           <a:p>
             <a:r>
-              <a:t>第三步，取這張圖裡最大的連通分量，當作捷徑。只有這些物品會被拿去訓練和推論推薦模型，其他的就當作雜訊排除。</a:t>
+              <a:t>上面是短期演化分支，在每張子圖上各跑一次 GCN，再用 LSTM 把相鄰時段串起來，捕捉興趣一步步的變化，對最近的行為比較敏感。</a:t>
             </a:r>
           </a:p>
           <a:p/>
           <a:p>
             <a:r>
-              <a:t>這個設計的好處是它像一個前處理的過濾器，可以接在不同的推薦模型前面，文字模型 TASTE 和 ID 模型 BERT4Rec 都能用。</a:t>
+              <a:t>下面是長距離聚合分支，用 self-attention 看到目前為止所有點擊，再加上位置編碼，讓模型知道哪些點擊比較早、哪些比較新，補足 LSTM 只看相鄰時段的不足。</a:t>
+            </a:r>
+          </a:p>
+          <a:p/>
+          <a:p>
+            <a:r>
+              <a:t>最右邊是融合：使用者表示等於短期、長距離、全域三個 embedding 相加，再跟新聞的 embedding 做內積，經過 sigmoid 得到點擊機率。</a:t>
             </a:r>
           </a:p>
         </p:txBody>
@@ -1606,25 +1594,37 @@
           <a:lstStyle/>
           <a:p>
             <a:r>
-              <a:t>Paper B：案例分析（1:00，累計 10:45）</a:t>
+              <a:t>Paper B：訓練目標（1:00，累計 10:45）</a:t>
             </a:r>
           </a:p>
           <a:p/>
           <a:p>
             <a:r>
-              <a:t>這是論文 Table 5 的實際例子，來自 Amazon Beauty。這個使用者點過四個商品，其中 n1、n2、n4 都是保濕乳液，彼此相似度大約 0.44 到 0.46；n3 是一瓶 Valentino 香水，跟其他商品的相似度只有 0.20 到 0.25。</a:t>
+              <a:t>訓練目標由三個部分組成。</a:t>
             </a:r>
           </a:p>
           <a:p/>
           <a:p>
             <a:r>
-              <a:t>所以建圖之後，邊只出現在 1、2、4 之間，香水是孤立的，最後留下來的捷徑就是 {1, 2, 4}。Yelp 的例子也一樣，一個常去酒吧和餐廳的使用者去過一次動物醫院，那筆紀錄就被濾掉了。</a:t>
+              <a:t>第一是預測損失，在每個時段內用 binary cross-entropy，每個正樣本搭配四個負樣本。</a:t>
             </a:r>
           </a:p>
           <a:p/>
           <a:p>
             <a:r>
-              <a:t>這種做法最大的優點是可解釋：我們可以清楚看到哪些點擊被移除、為什麼被移除。</a:t>
+              <a:t>第二是一致性正則化，用對比學習讓同一個使用者在某個時段的 embedding 靠近他自己的全域 embedding，並遠離其他使用者，避免時序表示偏離太多。</a:t>
+            </a:r>
+          </a:p>
+          <a:p/>
+          <a:p>
+            <a:r>
+              <a:t>第三是平滑正則化，讓相鄰時段的 embedding 不要差太多，因為興趣通常是漸進改變，不會突然跳很遠。</a:t>
+            </a:r>
+          </a:p>
+          <a:p/>
+          <a:p>
+            <a:r>
+              <a:t>實驗用的是兩個大型新聞資料集：Adressa 有三百六十萬使用者、三千五百萬筆點擊，橫跨三個月；MIND 有一百萬使用者、兩千四百萬筆點擊。評估指標是 AUC、MRR 和 nDCG，跟七個 baseline 比較。</a:t>
             </a:r>
           </a:p>
         </p:txBody>
@@ -4826,7 +4826,7 @@
                 </a:solidFill>
                 <a:latin typeface="Calibri"/>
               </a:rPr>
-              <a:t>Modeling Stage-wise Evolution of User Interests for News Recommendation</a:t>
+              <a:t>LISRec: Modeling User Preferences with Learned Item Shortcuts for Sequential Recommendation</a:t>
             </a:r>
           </a:p>
         </p:txBody>
@@ -4861,7 +4861,7 @@
                 </a:solidFill>
                 <a:latin typeface="Calibri"/>
               </a:rPr>
-              <a:t>Cheng, Jin, Zhang, Chen, Duan, Wang · WWW '26</a:t>
+              <a:t>Xin, Liu, Mei, Yan, Yu, Wang, Chen, Gu, Yu, Xiong · KDD '26</a:t>
             </a:r>
           </a:p>
         </p:txBody>
@@ -4949,7 +4949,7 @@
                 </a:solidFill>
                 <a:latin typeface="Calibri"/>
               </a:rPr>
-              <a:t>LISRec: Modeling User Preferences with Learned Item Shortcuts for Sequential Recommendation</a:t>
+              <a:t>Modeling Stage-wise Evolution of User Interests for News Recommendation</a:t>
             </a:r>
           </a:p>
         </p:txBody>
@@ -4984,7 +4984,7 @@
                 </a:solidFill>
                 <a:latin typeface="Calibri"/>
               </a:rPr>
-              <a:t>Xin, Liu, Mei, Yan, Yu, Wang, Chen, Gu, Yu, Xiong · KDD '26</a:t>
+              <a:t>Cheng, Jin, Zhang, Chen, Duan, Wang · WWW '26</a:t>
             </a:r>
           </a:p>
         </p:txBody>
@@ -5098,14 +5098,14 @@
                 </a:solidFill>
                 <a:latin typeface="Cambria"/>
               </a:rPr>
-              <a:t>Results: consistent gains on four datasets</a:t>
+              <a:t>Results: large gains, especially on Adressa</a:t>
             </a:r>
           </a:p>
         </p:txBody>
       </p:sp>
       <p:pic>
         <p:nvPicPr>
-          <p:cNvPr id="4" name="Picture 3" descr="b_tab1_results.png"/>
+          <p:cNvPr id="4" name="Picture 3" descr="b_tab2_results.png"/>
           <p:cNvPicPr>
             <a:picLocks noChangeAspect="1"/>
           </p:cNvPicPr>
@@ -5119,8 +5119,8 @@
         </p:blipFill>
         <p:spPr>
           <a:xfrm>
-            <a:off x="548640" y="1478971"/>
-            <a:ext cx="7680960" cy="2665617"/>
+            <a:off x="548640" y="1805858"/>
+            <a:ext cx="7498078" cy="1920403"/>
           </a:xfrm>
           <a:prstGeom prst="rect">
             <a:avLst/>
@@ -5140,8 +5140,8 @@
         </p:nvSpPr>
         <p:spPr>
           <a:xfrm>
-            <a:off x="548640" y="4217740"/>
-            <a:ext cx="7680960" cy="274320"/>
+            <a:off x="548640" y="3799413"/>
+            <a:ext cx="7498079" cy="274320"/>
           </a:xfrm>
           <a:prstGeom prst="rect">
             <a:avLst/>
@@ -5162,14 +5162,14 @@
                 </a:solidFill>
                 <a:latin typeface="Calibri"/>
               </a:rPr>
-              <a:t>Table 1 of Paper B: overall performance (Recall / NDCG @10, @20)</a:t>
+              <a:t>Table 2 of Paper B: comparison with baselines</a:t>
             </a:r>
           </a:p>
         </p:txBody>
       </p:sp>
       <p:pic>
         <p:nvPicPr>
-          <p:cNvPr id="6" name="Picture 5" descr="b_fig3_tau.png"/>
+          <p:cNvPr id="6" name="Picture 5" descr="b_tab3_ablation.png"/>
           <p:cNvPicPr>
             <a:picLocks noChangeAspect="1"/>
           </p:cNvPicPr>
@@ -5183,8 +5183,8 @@
         </p:blipFill>
         <p:spPr>
           <a:xfrm>
-            <a:off x="739100" y="4617720"/>
-            <a:ext cx="3368119" cy="1508760"/>
+            <a:off x="548640" y="4601718"/>
+            <a:ext cx="3657600" cy="1449324"/>
           </a:xfrm>
           <a:prstGeom prst="rect">
             <a:avLst/>
@@ -5204,8 +5204,8 @@
         </p:nvSpPr>
         <p:spPr>
           <a:xfrm>
-            <a:off x="548640" y="6199632"/>
-            <a:ext cx="3749039" cy="274320"/>
+            <a:off x="548640" y="6124194"/>
+            <a:ext cx="3657600" cy="274320"/>
           </a:xfrm>
           <a:prstGeom prst="rect">
             <a:avLst/>
@@ -5226,14 +5226,14 @@
                 </a:solidFill>
                 <a:latin typeface="Calibri"/>
               </a:rPr>
-              <a:t>Figure 3: threshold τ sensitivity</a:t>
+              <a:t>Table 3: ablation (Adressa)</a:t>
             </a:r>
           </a:p>
         </p:txBody>
       </p:sp>
       <p:pic>
         <p:nvPicPr>
-          <p:cNvPr id="8" name="Picture 7" descr="b_fig6_effect.png"/>
+          <p:cNvPr id="8" name="Picture 7" descr="b_fig2_window.png"/>
           <p:cNvPicPr>
             <a:picLocks noChangeAspect="1"/>
           </p:cNvPicPr>
@@ -5247,8 +5247,8 @@
         </p:blipFill>
         <p:spPr>
           <a:xfrm>
-            <a:off x="4897063" y="4617720"/>
-            <a:ext cx="2916033" cy="1508760"/>
+            <a:off x="4389120" y="4658792"/>
+            <a:ext cx="3657600" cy="1335176"/>
           </a:xfrm>
           <a:prstGeom prst="rect">
             <a:avLst/>
@@ -5268,8 +5268,8 @@
         </p:nvSpPr>
         <p:spPr>
           <a:xfrm>
-            <a:off x="4480560" y="6199632"/>
-            <a:ext cx="3749039" cy="274320"/>
+            <a:off x="4389120" y="6067120"/>
+            <a:ext cx="3657600" cy="274320"/>
           </a:xfrm>
           <a:prstGeom prst="rect">
             <a:avLst/>
@@ -5290,7 +5290,7 @@
                 </a:solidFill>
                 <a:latin typeface="Calibri"/>
               </a:rPr>
-              <a:t>Figure 6: closer user–target, outliers pushed out</a:t>
+              <a:t>Figure 2: window size</a:t>
             </a:r>
           </a:p>
         </p:txBody>
@@ -5303,8 +5303,8 @@
         </p:nvSpPr>
         <p:spPr>
           <a:xfrm>
-            <a:off x="8595360" y="1417320"/>
-            <a:ext cx="3047695" cy="777240"/>
+            <a:off x="8412480" y="1417320"/>
+            <a:ext cx="3230575" cy="777240"/>
           </a:xfrm>
           <a:prstGeom prst="rect">
             <a:avLst/>
@@ -5325,7 +5325,7 @@
                 </a:solidFill>
                 <a:latin typeface="Cambria"/>
               </a:rPr>
-              <a:t>+13%</a:t>
+              <a:t>0.80</a:t>
             </a:r>
           </a:p>
         </p:txBody>
@@ -5338,8 +5338,8 @@
         </p:nvSpPr>
         <p:spPr>
           <a:xfrm>
-            <a:off x="8595360" y="2194560"/>
-            <a:ext cx="3047695" cy="640080"/>
+            <a:off x="8412480" y="2194560"/>
+            <a:ext cx="3230575" cy="640080"/>
           </a:xfrm>
           <a:prstGeom prst="rect">
             <a:avLst/>
@@ -5360,7 +5360,7 @@
                 </a:solidFill>
                 <a:latin typeface="Calibri"/>
               </a:rPr>
-              <a:t>best improvement over baselines (Beauty)</a:t>
+              <a:t>AUC on Adressa vs 0.66 for best baseline (CROWN)</a:t>
             </a:r>
           </a:p>
         </p:txBody>
@@ -5373,8 +5373,8 @@
         </p:nvSpPr>
         <p:spPr>
           <a:xfrm>
-            <a:off x="8595360" y="2880360"/>
-            <a:ext cx="3047695" cy="777240"/>
+            <a:off x="8412480" y="2880360"/>
+            <a:ext cx="3230575" cy="777240"/>
           </a:xfrm>
           <a:prstGeom prst="rect">
             <a:avLst/>
@@ -5395,7 +5395,7 @@
                 </a:solidFill>
                 <a:latin typeface="Cambria"/>
               </a:rPr>
-              <a:t>+4.7%</a:t>
+              <a:t>0.58</a:t>
             </a:r>
           </a:p>
         </p:txBody>
@@ -5408,8 +5408,8 @@
         </p:nvSpPr>
         <p:spPr>
           <a:xfrm>
-            <a:off x="8595360" y="3657600"/>
-            <a:ext cx="3047695" cy="640080"/>
+            <a:off x="8412480" y="3657600"/>
+            <a:ext cx="3230575" cy="640080"/>
           </a:xfrm>
           <a:prstGeom prst="rect">
             <a:avLst/>
@@ -5430,7 +5430,7 @@
                 </a:solidFill>
                 <a:latin typeface="Calibri"/>
               </a:rPr>
-              <a:t>over denoising methods (DSAN, HSD, DCRec)</a:t>
+              <a:t>AUC on MIND vs 0.55 (smaller gain)</a:t>
             </a:r>
           </a:p>
         </p:txBody>
@@ -5443,8 +5443,8 @@
         </p:nvSpPr>
         <p:spPr>
           <a:xfrm>
-            <a:off x="8595360" y="4389120"/>
-            <a:ext cx="3047695" cy="2194560"/>
+            <a:off x="8412480" y="4389120"/>
+            <a:ext cx="3230575" cy="2194560"/>
           </a:xfrm>
           <a:prstGeom prst="rect">
             <a:avLst/>
@@ -5470,7 +5470,7 @@
                 </a:solidFill>
                 <a:latin typeface="Calibri"/>
               </a:rPr>
-              <a:t>Big gains on shopping data, small on Yelp</a:t>
+              <a:t>Removing any module hurts a lot</a:t>
             </a:r>
           </a:p>
           <a:p>
@@ -5481,13 +5481,22 @@
               <a:buChar char="•"/>
             </a:pPr>
             <a:r>
+              <a:rPr sz="1400" b="1" i="0">
+                <a:solidFill>
+                  <a:srgbClr val="1B263B"/>
+                </a:solidFill>
+                <a:latin typeface="Calibri"/>
+              </a:rPr>
+              <a:t>2-week window is best: </a:t>
+            </a:r>
+            <a:r>
               <a:rPr sz="1400" b="0" i="0">
                 <a:solidFill>
                   <a:srgbClr val="1B263B"/>
                 </a:solidFill>
                 <a:latin typeface="Calibri"/>
               </a:rPr>
-              <a:t>Even a zero-shot filter helps</a:t>
+              <a:t>shorter = too sparse, longer = blurs shifts</a:t>
             </a:r>
           </a:p>
         </p:txBody>
@@ -5608,8 +5617,8 @@
               </a:tblPr>
               <a:tblGrid>
                 <a:gridCol w="2651760"/>
-                <a:gridCol w="4343400"/>
-                <a:gridCol w="4096512"/>
+                <a:gridCol w="4224528"/>
+                <a:gridCol w="4215384"/>
               </a:tblGrid>
               <a:tr h="548640">
                 <a:tc>
@@ -5646,7 +5655,7 @@
                           </a:solidFill>
                           <a:latin typeface="Calibri"/>
                         </a:rPr>
-                        <a:t>Paper A · Stage-wise news rec</a:t>
+                        <a:t>Paper A · LISRec</a:t>
                       </a:r>
                     </a:p>
                   </a:txBody>
@@ -5668,7 +5677,7 @@
                           </a:solidFill>
                           <a:latin typeface="Calibri"/>
                         </a:rPr>
-                        <a:t>Paper B · LISRec</a:t>
+                        <a:t>Paper B · Stage-wise news rec</a:t>
                       </a:r>
                     </a:p>
                   </a:txBody>
@@ -5714,7 +5723,7 @@
                           </a:solidFill>
                           <a:latin typeface="Calibri"/>
                         </a:rPr>
-                        <a:t>History is static</a:t>
+                        <a:t>History is clean</a:t>
                       </a:r>
                     </a:p>
                   </a:txBody>
@@ -5736,7 +5745,7 @@
                           </a:solidFill>
                           <a:latin typeface="Calibri"/>
                         </a:rPr>
-                        <a:t>History is clean</a:t>
+                        <a:t>History is static</a:t>
                       </a:r>
                     </a:p>
                   </a:txBody>
@@ -5782,7 +5791,7 @@
                           </a:solidFill>
                           <a:latin typeface="Calibri"/>
                         </a:rPr>
-                        <a:t>Time stamps + collaborative graph</a:t>
+                        <a:t>Item text semantics</a:t>
                       </a:r>
                     </a:p>
                   </a:txBody>
@@ -5804,7 +5813,7 @@
                           </a:solidFill>
                           <a:latin typeface="Calibri"/>
                         </a:rPr>
-                        <a:t>Item text semantics</a:t>
+                        <a:t>Time stamps + collaborative graph</a:t>
                       </a:r>
                     </a:p>
                   </a:txBody>
@@ -5850,7 +5859,7 @@
                           </a:solidFill>
                           <a:latin typeface="Calibri"/>
                         </a:rPr>
-                        <a:t>Global + per-stage user–news graphs</a:t>
+                        <a:t>Per-user item-similarity graph</a:t>
                       </a:r>
                     </a:p>
                   </a:txBody>
@@ -5872,7 +5881,7 @@
                           </a:solidFill>
                           <a:latin typeface="Calibri"/>
                         </a:rPr>
-                        <a:t>Per-user item-similarity graph</a:t>
+                        <a:t>Global + per-stage user–news graphs</a:t>
                       </a:r>
                     </a:p>
                   </a:txBody>
@@ -5918,7 +5927,7 @@
                           </a:solidFill>
                           <a:latin typeface="Calibri"/>
                         </a:rPr>
-                        <a:t>GCN + LSTM + self-attention</a:t>
+                        <a:t>Largest connected component as filter</a:t>
                       </a:r>
                     </a:p>
                   </a:txBody>
@@ -5940,7 +5949,7 @@
                           </a:solidFill>
                           <a:latin typeface="Calibri"/>
                         </a:rPr>
-                        <a:t>Largest connected component as filter</a:t>
+                        <a:t>GCN + LSTM + self-attention</a:t>
                       </a:r>
                     </a:p>
                   </a:txBody>
@@ -5986,7 +5995,7 @@
                           </a:solidFill>
                           <a:latin typeface="Calibri"/>
                         </a:rPr>
-                        <a:t>News: Adressa, MIND (24–35M clicks)</a:t>
+                        <a:t>E-commerce &amp; POI: Amazon ×3, Yelp</a:t>
                       </a:r>
                     </a:p>
                   </a:txBody>
@@ -6008,7 +6017,7 @@
                           </a:solidFill>
                           <a:latin typeface="Calibri"/>
                         </a:rPr>
-                        <a:t>E-commerce &amp; POI: Amazon ×3, Yelp</a:t>
+                        <a:t>News: Adressa, MIND (24–35M clicks)</a:t>
                       </a:r>
                     </a:p>
                   </a:txBody>
@@ -6054,7 +6063,7 @@
                           </a:solidFill>
                           <a:latin typeface="Calibri"/>
                         </a:rPr>
-                        <a:t>AUC, MRR, nDCG@5/10</a:t>
+                        <a:t>Recall, NDCG @10/20</a:t>
                       </a:r>
                     </a:p>
                   </a:txBody>
@@ -6076,7 +6085,7 @@
                           </a:solidFill>
                           <a:latin typeface="Calibri"/>
                         </a:rPr>
-                        <a:t>Recall, NDCG @10/20</a:t>
+                        <a:t>AUC, MRR, nDCG@5/10</a:t>
                       </a:r>
                     </a:p>
                   </a:txBody>
@@ -6122,7 +6131,7 @@
                           </a:solidFill>
                           <a:latin typeface="Calibri"/>
                         </a:rPr>
-                        <a:t>No, end-to-end model</a:t>
+                        <a:t>Yes, pre-filter for any recommender</a:t>
                       </a:r>
                     </a:p>
                   </a:txBody>
@@ -6144,7 +6153,7 @@
                           </a:solidFill>
                           <a:latin typeface="Calibri"/>
                         </a:rPr>
-                        <a:t>Yes, pre-filter for any recommender</a:t>
+                        <a:t>No, end-to-end model</a:t>
                       </a:r>
                     </a:p>
                   </a:txBody>
@@ -6380,7 +6389,7 @@
                 </a:solidFill>
                 <a:latin typeface="Calibri"/>
               </a:rPr>
-              <a:t>Split history by time - a global graph for stable taste, stage subgraphs + LSTM / attention for drift</a:t>
+              <a:t>Split history by meaning - keep the semantically coherent core, drop outlier clicks</a:t>
             </a:r>
           </a:p>
           <a:p>
@@ -6406,7 +6415,7 @@
                 </a:solidFill>
                 <a:latin typeface="Calibri"/>
               </a:rPr>
-              <a:t>Split history by meaning - keep the semantically coherent core, drop outlier clicks</a:t>
+              <a:t>Split history by time - a global graph for stable taste, stage subgraphs + LSTM / attention for drift</a:t>
             </a:r>
           </a:p>
           <a:p>
@@ -6449,7 +6458,7 @@
                 </a:solidFill>
                 <a:latin typeface="Calibri"/>
               </a:rPr>
-              <a:t>Both report clear gains; B is plug-and-play and interpretable</a:t>
+              <a:t>Both report clear gains; A is plug-and-play and interpretable</a:t>
             </a:r>
           </a:p>
         </p:txBody>
@@ -6579,7 +6588,7 @@
                 </a:solidFill>
                 <a:latin typeface="Calibri"/>
               </a:rPr>
-              <a:t>Several baselines score AUC ≈ 0.50 on Adressa (near random) - is the setup fair to them?</a:t>
+              <a:t>Largest component keeps one dominant interest - what about users with several genuine interests?</a:t>
             </a:r>
           </a:p>
           <a:p>
@@ -6596,7 +6605,7 @@
                 </a:solidFill>
                 <a:latin typeface="Calibri"/>
               </a:rPr>
-              <a:t>A: </a:t>
+              <a:t>B: </a:t>
             </a:r>
             <a:r>
               <a:rPr sz="1500" b="0" i="0">
@@ -6605,7 +6614,7 @@
                 </a:solidFill>
                 <a:latin typeface="Calibri"/>
               </a:rPr>
-              <a:t>Fixed windows; MIND has no real time stamps, so its stages are pseudo-periods</a:t>
+              <a:t>Several baselines score AUC ≈ 0.50 on Adressa (near random) - is the setup fair to them?</a:t>
             </a:r>
           </a:p>
           <a:p>
@@ -6631,7 +6640,7 @@
                 </a:solidFill>
                 <a:latin typeface="Calibri"/>
               </a:rPr>
-              <a:t>Largest component keeps one dominant interest - what about users with several genuine interests?</a:t>
+              <a:t>Fixed windows; MIND has no real time stamps, so its stages are pseudo-periods</a:t>
             </a:r>
           </a:p>
           <a:p>
@@ -6648,7 +6657,7 @@
                 </a:solidFill>
                 <a:latin typeface="Calibri"/>
               </a:rPr>
-              <a:t>Combine them? Denoise with B, then model stage-wise drift with A</a:t>
+              <a:t>Combine them? Denoise with A, then model stage-wise drift with B</a:t>
             </a:r>
           </a:p>
         </p:txBody>
@@ -6729,7 +6738,7 @@
                 </a:solidFill>
                 <a:latin typeface="Calibri"/>
               </a:rPr>
-              <a:t>Better recommendations start with a better view of the history: when an interest matters (A) and which clicks really count (B).</a:t>
+              <a:t>Better recommendations start with a better view of the history: which clicks really count (A) and when an interest matters (B).</a:t>
             </a:r>
           </a:p>
         </p:txBody>
@@ -6913,7 +6922,7 @@
                 </a:solidFill>
                 <a:latin typeface="Calibri"/>
               </a:rPr>
-              <a:t>Cheng et al. Modeling Stage-wise Evolution of User Interests for News Recommendation. WWW '26. arXiv:2603.10471 · github.com/yikeJin/SEIN</a:t>
+              <a:t>Xin et al. LISRec: Modeling User Preferences with Learned Item Shortcuts for Sequential Recommendation. KDD '26. doi:10.1145/3770854.3780337 · github.com/NEUIR/LISRec</a:t>
             </a:r>
           </a:p>
         </p:txBody>
@@ -7001,7 +7010,7 @@
                 </a:solidFill>
                 <a:latin typeface="Calibri"/>
               </a:rPr>
-              <a:t>Xin et al. LISRec: Modeling User Preferences with Learned Item Shortcuts for Sequential Recommendation. KDD '26. doi:10.1145/3770854.3780337 · github.com/NEUIR/LISRec</a:t>
+              <a:t>Cheng et al. Modeling Stage-wise Evolution of User Interests for News Recommendation. WWW '26. arXiv:2603.10471 · github.com/yikeJin/SEIN</a:t>
             </a:r>
           </a:p>
         </p:txBody>
@@ -7294,7 +7303,7 @@
                 </a:solidFill>
                 <a:latin typeface="Calibri"/>
               </a:rPr>
-              <a:t>Raw histories are treated as a clean, static signal. Paper A says it is not static (interests drift); Paper B says it is not clean (noisy clicks).</a:t>
+              <a:t>Raw histories are treated as a clean, static signal. Paper A says it is not clean (noisy clicks); Paper B says it is not static (interests drift).</a:t>
             </a:r>
           </a:p>
         </p:txBody>
@@ -7410,7 +7419,7 @@
                 </a:solidFill>
                 <a:latin typeface="Calibri"/>
               </a:rPr>
-              <a:t>Accepted at WWW '26 and KDD '26, top venues for web / data mining; both release code, and both use graphs to restructure the history.</a:t>
+              <a:t>Accepted at KDD '26 and WWW '26, top venues for web / data mining; both release code, and both use graphs to restructure the history.</a:t>
             </a:r>
           </a:p>
         </p:txBody>
@@ -7579,7 +7588,7 @@
                 </a:solidFill>
                 <a:latin typeface="Calibri"/>
               </a:rPr>
-              <a:t>Time: interests evolve</a:t>
+              <a:t>Semantics: some clicks are noise</a:t>
             </a:r>
           </a:p>
         </p:txBody>
@@ -7614,7 +7623,7 @@
                 </a:solidFill>
                 <a:latin typeface="Calibri"/>
               </a:rPr>
-              <a:t>Split the history into time stages and model how preferences move from stage to stage.</a:t>
+              <a:t>Keep only the items that are semantically consistent with each other; drop the outliers.</a:t>
             </a:r>
           </a:p>
         </p:txBody>
@@ -7748,7 +7757,7 @@
                 </a:solidFill>
                 <a:latin typeface="Calibri"/>
               </a:rPr>
-              <a:t>Semantics: some clicks are noise</a:t>
+              <a:t>Time: interests evolve</a:t>
             </a:r>
           </a:p>
         </p:txBody>
@@ -7783,7 +7792,7 @@
                 </a:solidFill>
                 <a:latin typeface="Calibri"/>
               </a:rPr>
-              <a:t>Keep only the items that are semantically consistent with each other; drop the outliers.</a:t>
+              <a:t>Split the history into time stages and model how preferences move from stage to stage.</a:t>
             </a:r>
           </a:p>
         </p:txBody>
@@ -7932,7 +7941,7 @@
                 </a:solidFill>
                 <a:latin typeface="Cambria"/>
               </a:rPr>
-              <a:t>News interests are time-sensitive</a:t>
+              <a:t>Not every click reflects a real preference</a:t>
             </a:r>
           </a:p>
         </p:txBody>
@@ -7967,21 +7976,85 @@
                 </a:solidFill>
                 <a:latin typeface="Calibri"/>
               </a:rPr>
-              <a:t>Modeling Stage-wise Evolution of User Interests for News Recommendation · WWW '26</a:t>
-            </a:r>
-          </a:p>
-        </p:txBody>
-      </p:sp>
-      <p:sp>
-        <p:nvSpPr>
-          <p:cNvPr id="5" name="TextBox 4"/>
+              <a:t>LISRec: Modeling User Preferences with Learned Item Shortcuts · KDD '26</a:t>
+            </a:r>
+          </a:p>
+        </p:txBody>
+      </p:sp>
+      <p:pic>
+        <p:nvPicPr>
+          <p:cNvPr id="5" name="Picture 4" descr="a_fig1_idea.png"/>
+          <p:cNvPicPr>
+            <a:picLocks noChangeAspect="1"/>
+          </p:cNvPicPr>
+          <p:nvPr/>
+        </p:nvPicPr>
+        <p:blipFill>
+          <a:blip r:embed="rId2"/>
+          <a:stretch>
+            <a:fillRect/>
+          </a:stretch>
+        </p:blipFill>
+        <p:spPr>
+          <a:xfrm>
+            <a:off x="1247892" y="1417320"/>
+            <a:ext cx="3722135" cy="4617720"/>
+          </a:xfrm>
+          <a:prstGeom prst="rect">
+            <a:avLst/>
+          </a:prstGeom>
+          <a:ln w="9525">
+            <a:solidFill>
+              <a:srgbClr val="D5DAE1"/>
+            </a:solidFill>
+          </a:ln>
+        </p:spPr>
+      </p:pic>
+      <p:sp>
+        <p:nvSpPr>
+          <p:cNvPr id="6" name="TextBox 5"/>
           <p:cNvSpPr txBox="1"/>
           <p:nvPr/>
         </p:nvSpPr>
         <p:spPr>
           <a:xfrm>
-            <a:off x="548640" y="1691640"/>
-            <a:ext cx="5760720" cy="4114800"/>
+            <a:off x="548640" y="6108192"/>
+            <a:ext cx="5120640" cy="274320"/>
+          </a:xfrm>
+          <a:prstGeom prst="rect">
+            <a:avLst/>
+          </a:prstGeom>
+          <a:noFill/>
+        </p:spPr>
+        <p:txBody>
+          <a:bodyPr wrap="square" anchor="t" lIns="0" rIns="0" tIns="0" bIns="0">
+            <a:spAutoFit/>
+          </a:bodyPr>
+          <a:lstStyle/>
+          <a:p>
+            <a:pPr algn="ctr"/>
+            <a:r>
+              <a:rPr sz="1100" b="0" i="1">
+                <a:solidFill>
+                  <a:srgbClr val="5B677A"/>
+                </a:solidFill>
+                <a:latin typeface="Calibri"/>
+              </a:rPr>
+              <a:t>Figure 1 of Paper A: a LEGO fan clicks a Nintendo Switch</a:t>
+            </a:r>
+          </a:p>
+        </p:txBody>
+      </p:sp>
+      <p:sp>
+        <p:nvSpPr>
+          <p:cNvPr id="7" name="TextBox 6"/>
+          <p:cNvSpPr txBox="1"/>
+          <p:nvPr/>
+        </p:nvSpPr>
+        <p:spPr>
+          <a:xfrm>
+            <a:off x="6035040" y="1600200"/>
+            <a:ext cx="5608015" cy="3108960"/>
           </a:xfrm>
           <a:prstGeom prst="rect">
             <a:avLst/>
@@ -8001,22 +8074,22 @@
               <a:buChar char="•"/>
             </a:pPr>
             <a:r>
-              <a:rPr sz="1700" b="1" i="0">
+              <a:rPr sz="1600" b="1" i="0">
                 <a:solidFill>
                   <a:srgbClr val="1B263B"/>
                 </a:solidFill>
                 <a:latin typeface="Calibri"/>
               </a:rPr>
-              <a:t>News loses value fast: </a:t>
-            </a:r>
-            <a:r>
-              <a:rPr sz="1700" b="0" i="0">
+              <a:t>Histories contain noise: </a:t>
+            </a:r>
+            <a:r>
+              <a:rPr sz="1600" b="0" i="0">
                 <a:solidFill>
                   <a:srgbClr val="1B263B"/>
                 </a:solidFill>
                 <a:latin typeface="Calibri"/>
               </a:rPr>
-              <a:t>users want the latest events, trending topics, seasonal contexts</a:t>
+              <a:t>accidental clicks, momentary curiosity</a:t>
             </a:r>
           </a:p>
           <a:p>
@@ -8027,39 +8100,13 @@
               <a:buChar char="•"/>
             </a:pPr>
             <a:r>
-              <a:rPr sz="1700" b="1" i="0">
+              <a:rPr sz="1600" b="0" i="0">
                 <a:solidFill>
                   <a:srgbClr val="1B263B"/>
                 </a:solidFill>
                 <a:latin typeface="Calibri"/>
               </a:rPr>
-              <a:t>Two kinds of interest: </a:t>
-            </a:r>
-            <a:r>
-              <a:rPr sz="1700" b="0" i="0">
-                <a:solidFill>
-                  <a:srgbClr val="1B263B"/>
-                </a:solidFill>
-                <a:latin typeface="Calibri"/>
-              </a:rPr>
-              <a:t>stable long-term reading habits + short-term, event-driven shifts</a:t>
-            </a:r>
-          </a:p>
-          <a:p>
-            <a:pPr marL="530352" indent="-219456">
-              <a:spcAft>
-                <a:spcPts val="800"/>
-              </a:spcAft>
-              <a:buChar char="–"/>
-            </a:pPr>
-            <a:r>
-              <a:rPr sz="1500" b="0" i="0">
-                <a:solidFill>
-                  <a:srgbClr val="1B263B"/>
-                </a:solidFill>
-                <a:latin typeface="Calibri"/>
-              </a:rPr>
-              <a:t>e.g. World Cup → sports spike; pandemic → health news spike</a:t>
+              <a:t>ID-based (SASRec, BERT4Rec) and text-based (TASTE, HLLM) models use every item equally → noise propagates</a:t>
             </a:r>
           </a:p>
           <a:p>
@@ -8070,22 +8117,13 @@
               <a:buChar char="•"/>
             </a:pPr>
             <a:r>
-              <a:rPr sz="1700" b="1" i="0">
+              <a:rPr sz="1600" b="0" i="0">
                 <a:solidFill>
                   <a:srgbClr val="1B263B"/>
                 </a:solidFill>
                 <a:latin typeface="Calibri"/>
               </a:rPr>
-              <a:t>Static global graph (GCN): </a:t>
-            </a:r>
-            <a:r>
-              <a:rPr sz="1700" b="0" i="0">
-                <a:solidFill>
-                  <a:srgbClr val="1B263B"/>
-                </a:solidFill>
-                <a:latin typeface="Calibri"/>
-              </a:rPr>
-              <a:t>good collaborative signal, but outdated recommendations</a:t>
+              <a:t>Existing denoising re-weights items or uses implicit contrastive learning → no explicit removal, hard to interpret</a:t>
             </a:r>
           </a:p>
           <a:p>
@@ -8096,62 +8134,36 @@
               <a:buChar char="•"/>
             </a:pPr>
             <a:r>
-              <a:rPr sz="1700" b="1" i="0">
+              <a:rPr sz="1600" b="1" i="0">
                 <a:solidFill>
                   <a:srgbClr val="1B263B"/>
                 </a:solidFill>
                 <a:latin typeface="Calibri"/>
               </a:rPr>
-              <a:t>Sequential models (LSTUR, ...): </a:t>
-            </a:r>
-            <a:r>
-              <a:rPr sz="1700" b="0" i="0">
+              <a:t>Idea: </a:t>
+            </a:r>
+            <a:r>
+              <a:rPr sz="1600" b="0" i="0">
                 <a:solidFill>
                   <a:srgbClr val="1B263B"/>
                 </a:solidFill>
                 <a:latin typeface="Calibri"/>
               </a:rPr>
-              <a:t>track recency, but lose stable high-order signals</a:t>
-            </a:r>
-          </a:p>
-          <a:p>
-            <a:pPr marL="256032" indent="-219456">
-              <a:spcAft>
-                <a:spcPts val="800"/>
-              </a:spcAft>
-              <a:buChar char="•"/>
-            </a:pPr>
-            <a:r>
-              <a:rPr sz="1700" b="1" i="0">
-                <a:solidFill>
-                  <a:srgbClr val="1B263B"/>
-                </a:solidFill>
-                <a:latin typeface="Calibri"/>
-              </a:rPr>
-              <a:t>Goal: </a:t>
-            </a:r>
-            <a:r>
-              <a:rPr sz="1700" b="0" i="0">
-                <a:solidFill>
-                  <a:srgbClr val="1B263B"/>
-                </a:solidFill>
-                <a:latin typeface="Calibri"/>
-              </a:rPr>
-              <a:t>keep long-term stability and stay sensitive to short-term change</a:t>
-            </a:r>
-          </a:p>
-        </p:txBody>
-      </p:sp>
-      <p:sp>
-        <p:nvSpPr>
-          <p:cNvPr id="6" name="Rounded Rectangle 5"/>
+              <a:t>find the semantic "shortcut" - the subset of items that agree with each other - and model the user from it</a:t>
+            </a:r>
+          </a:p>
+        </p:txBody>
+      </p:sp>
+      <p:sp>
+        <p:nvSpPr>
+          <p:cNvPr id="8" name="Rounded Rectangle 7"/>
           <p:cNvSpPr/>
           <p:nvPr/>
         </p:nvSpPr>
         <p:spPr>
           <a:xfrm>
-            <a:off x="6766560" y="1691640"/>
-            <a:ext cx="4876495" cy="1691640"/>
+            <a:off x="6035040" y="4160520"/>
+            <a:ext cx="5608015" cy="1097280"/>
           </a:xfrm>
           <a:prstGeom prst="roundRect">
             <a:avLst>
@@ -8190,14 +8202,14 @@
       </p:sp>
       <p:sp>
         <p:nvSpPr>
-          <p:cNvPr id="7" name="TextBox 6"/>
+          <p:cNvPr id="9" name="TextBox 8"/>
           <p:cNvSpPr txBox="1"/>
           <p:nvPr/>
         </p:nvSpPr>
         <p:spPr>
           <a:xfrm>
-            <a:off x="6995160" y="1874520"/>
-            <a:ext cx="4419295" cy="411480"/>
+            <a:off x="6263640" y="4251960"/>
+            <a:ext cx="5150815" cy="914400"/>
           </a:xfrm>
           <a:prstGeom prst="rect">
             <a:avLst/>
@@ -8205,213 +8217,27 @@
           <a:noFill/>
         </p:spPr>
         <p:txBody>
-          <a:bodyPr wrap="square" anchor="t" lIns="0" rIns="0" tIns="0" bIns="0">
+          <a:bodyPr wrap="square" anchor="ctr" lIns="0" rIns="0" tIns="0" bIns="0">
             <a:spAutoFit/>
           </a:bodyPr>
           <a:lstStyle/>
           <a:p>
             <a:pPr algn="l"/>
             <a:r>
-              <a:rPr sz="1800" b="1" i="0">
-                <a:solidFill>
-                  <a:srgbClr val="3D6B73"/>
-                </a:solidFill>
-                <a:latin typeface="Cambria"/>
-              </a:rPr>
-              <a:t>Static models</a:t>
-            </a:r>
-          </a:p>
-        </p:txBody>
-      </p:sp>
-      <p:sp>
-        <p:nvSpPr>
-          <p:cNvPr id="8" name="TextBox 7"/>
-          <p:cNvSpPr txBox="1"/>
-          <p:nvPr/>
-        </p:nvSpPr>
-        <p:spPr>
-          <a:xfrm>
-            <a:off x="6995160" y="2331720"/>
-            <a:ext cx="4419295" cy="960120"/>
-          </a:xfrm>
-          <a:prstGeom prst="rect">
-            <a:avLst/>
-          </a:prstGeom>
-          <a:noFill/>
-        </p:spPr>
-        <p:txBody>
-          <a:bodyPr wrap="square" anchor="t" lIns="0" rIns="0" tIns="0" bIns="0">
-            <a:spAutoFit/>
-          </a:bodyPr>
-          <a:lstStyle/>
-          <a:p>
-            <a:pPr algn="l"/>
-            <a:r>
-              <a:rPr sz="1400" b="0" i="0">
+              <a:rPr sz="1500" b="0" i="0">
                 <a:solidFill>
                   <a:srgbClr val="1B263B"/>
                 </a:solidFill>
                 <a:latin typeface="Calibri"/>
               </a:rPr>
-              <a:t>One graph over all time → a user's 3-month-old interest weighs as much as yesterday's. Profiles become dominated by outdated clicks.</a:t>
-            </a:r>
-          </a:p>
-        </p:txBody>
-      </p:sp>
-      <p:sp>
-        <p:nvSpPr>
-          <p:cNvPr id="9" name="Rounded Rectangle 8"/>
-          <p:cNvSpPr/>
-          <p:nvPr/>
-        </p:nvSpPr>
-        <p:spPr>
-          <a:xfrm>
-            <a:off x="6766560" y="3611880"/>
-            <a:ext cx="4876495" cy="1691640"/>
-          </a:xfrm>
-          <a:prstGeom prst="roundRect">
-            <a:avLst>
-              <a:gd name="adj" fmla="val 8000"/>
-            </a:avLst>
-          </a:prstGeom>
-          <a:solidFill>
-            <a:srgbClr val="F2F3F5"/>
-          </a:solidFill>
-          <a:ln>
-            <a:noFill/>
-          </a:ln>
-          <a:effectLst/>
-        </p:spPr>
-        <p:style>
-          <a:lnRef idx="1">
-            <a:schemeClr val="accent1"/>
-          </a:lnRef>
-          <a:fillRef idx="3">
-            <a:schemeClr val="accent1"/>
-          </a:fillRef>
-          <a:effectRef idx="2">
-            <a:schemeClr val="accent1"/>
-          </a:effectRef>
-          <a:fontRef idx="minor">
-            <a:schemeClr val="lt1"/>
-          </a:fontRef>
-        </p:style>
-        <p:txBody>
-          <a:bodyPr rtlCol="0" anchor="ctr"/>
-          <a:lstStyle/>
-          <a:p>
-            <a:pPr algn="ctr"/>
+              <a:t>History [LEGO Iron Man, LEGO Stitch, LEGO Bugatti, Switch Mario Kart, LEGO R2-D2] → shortcut keeps the LEGO items and drops the Switch.</a:t>
+            </a:r>
           </a:p>
         </p:txBody>
       </p:sp>
       <p:sp>
         <p:nvSpPr>
           <p:cNvPr id="10" name="TextBox 9"/>
-          <p:cNvSpPr txBox="1"/>
-          <p:nvPr/>
-        </p:nvSpPr>
-        <p:spPr>
-          <a:xfrm>
-            <a:off x="6995160" y="3794760"/>
-            <a:ext cx="4419295" cy="411480"/>
-          </a:xfrm>
-          <a:prstGeom prst="rect">
-            <a:avLst/>
-          </a:prstGeom>
-          <a:noFill/>
-        </p:spPr>
-        <p:txBody>
-          <a:bodyPr wrap="square" anchor="t" lIns="0" rIns="0" tIns="0" bIns="0">
-            <a:spAutoFit/>
-          </a:bodyPr>
-          <a:lstStyle/>
-          <a:p>
-            <a:pPr algn="l"/>
-            <a:r>
-              <a:rPr sz="1800" b="1" i="0">
-                <a:solidFill>
-                  <a:srgbClr val="3D6B73"/>
-                </a:solidFill>
-                <a:latin typeface="Cambria"/>
-              </a:rPr>
-              <a:t>Pure sequential models</a:t>
-            </a:r>
-          </a:p>
-        </p:txBody>
-      </p:sp>
-      <p:sp>
-        <p:nvSpPr>
-          <p:cNvPr id="11" name="TextBox 10"/>
-          <p:cNvSpPr txBox="1"/>
-          <p:nvPr/>
-        </p:nvSpPr>
-        <p:spPr>
-          <a:xfrm>
-            <a:off x="6995160" y="4251960"/>
-            <a:ext cx="4419295" cy="960120"/>
-          </a:xfrm>
-          <a:prstGeom prst="rect">
-            <a:avLst/>
-          </a:prstGeom>
-          <a:noFill/>
-        </p:spPr>
-        <p:txBody>
-          <a:bodyPr wrap="square" anchor="t" lIns="0" rIns="0" tIns="0" bIns="0">
-            <a:spAutoFit/>
-          </a:bodyPr>
-          <a:lstStyle/>
-          <a:p>
-            <a:pPr algn="l"/>
-            <a:r>
-              <a:rPr sz="1400" b="0" i="0">
-                <a:solidFill>
-                  <a:srgbClr val="1B263B"/>
-                </a:solidFill>
-                <a:latin typeface="Calibri"/>
-              </a:rPr>
-              <a:t>Focus on the latest clicks → over-react to temporary trends and miss the collaborative structure of the whole graph.</a:t>
-            </a:r>
-          </a:p>
-        </p:txBody>
-      </p:sp>
-      <p:sp>
-        <p:nvSpPr>
-          <p:cNvPr id="12" name="TextBox 11"/>
-          <p:cNvSpPr txBox="1"/>
-          <p:nvPr/>
-        </p:nvSpPr>
-        <p:spPr>
-          <a:xfrm>
-            <a:off x="6766560" y="5532120"/>
-            <a:ext cx="4876495" cy="640080"/>
-          </a:xfrm>
-          <a:prstGeom prst="rect">
-            <a:avLst/>
-          </a:prstGeom>
-          <a:noFill/>
-        </p:spPr>
-        <p:txBody>
-          <a:bodyPr wrap="square" anchor="t" lIns="0" rIns="0" tIns="0" bIns="0">
-            <a:spAutoFit/>
-          </a:bodyPr>
-          <a:lstStyle/>
-          <a:p>
-            <a:pPr algn="l"/>
-            <a:r>
-              <a:rPr sz="1400" b="0" i="1">
-                <a:solidFill>
-                  <a:srgbClr val="1B263B"/>
-                </a:solidFill>
-                <a:latin typeface="Calibri"/>
-              </a:rPr>
-              <a:t>Key insight: clicks inside one period are coherent; transitions across periods show the evolution.</a:t>
-            </a:r>
-          </a:p>
-        </p:txBody>
-      </p:sp>
-      <p:sp>
-        <p:nvSpPr>
-          <p:cNvPr id="13" name="TextBox 12"/>
           <p:cNvSpPr txBox="1"/>
           <p:nvPr/>
         </p:nvSpPr>
@@ -8553,14 +8379,14 @@
                 </a:solidFill>
                 <a:latin typeface="Cambria"/>
               </a:rPr>
-              <a:t>Framework: global graph + stage-wise subgraphs</a:t>
+              <a:t>LISRec pipeline: encode → build graph → keep the core</a:t>
             </a:r>
           </a:p>
         </p:txBody>
       </p:sp>
       <p:pic>
         <p:nvPicPr>
-          <p:cNvPr id="4" name="Picture 3" descr="a_fig1_framework.png"/>
+          <p:cNvPr id="4" name="Picture 3" descr="a_fig2_arch.png"/>
           <p:cNvPicPr>
             <a:picLocks noChangeAspect="1"/>
           </p:cNvPicPr>
@@ -8574,8 +8400,8 @@
         </p:blipFill>
         <p:spPr>
           <a:xfrm>
-            <a:off x="548640" y="2015901"/>
-            <a:ext cx="7589520" cy="3329118"/>
+            <a:off x="548640" y="1731114"/>
+            <a:ext cx="7315200" cy="3898692"/>
           </a:xfrm>
           <a:prstGeom prst="rect">
             <a:avLst/>
@@ -8595,8 +8421,8 @@
         </p:nvSpPr>
         <p:spPr>
           <a:xfrm>
-            <a:off x="548640" y="5418171"/>
-            <a:ext cx="7589520" cy="274320"/>
+            <a:off x="548640" y="5702958"/>
+            <a:ext cx="7315200" cy="274320"/>
           </a:xfrm>
           <a:prstGeom prst="rect">
             <a:avLst/>
@@ -8617,21 +8443,74 @@
                 </a:solidFill>
                 <a:latin typeface="Calibri"/>
               </a:rPr>
-              <a:t>Figure 1 of Paper A: overall framework</a:t>
-            </a:r>
-          </a:p>
-        </p:txBody>
-      </p:sp>
-      <p:sp>
-        <p:nvSpPr>
-          <p:cNvPr id="6" name="TextBox 5"/>
+              <a:t>Figure 2 of Paper A: model architecture</a:t>
+            </a:r>
+          </a:p>
+        </p:txBody>
+      </p:sp>
+      <p:sp>
+        <p:nvSpPr>
+          <p:cNvPr id="6" name="Oval 5"/>
+          <p:cNvSpPr/>
+          <p:nvPr/>
+        </p:nvSpPr>
+        <p:spPr>
+          <a:xfrm>
+            <a:off x="8138160" y="1508760"/>
+            <a:ext cx="457200" cy="457200"/>
+          </a:xfrm>
+          <a:prstGeom prst="ellipse">
+            <a:avLst/>
+          </a:prstGeom>
+          <a:solidFill>
+            <a:srgbClr val="3D6B73"/>
+          </a:solidFill>
+          <a:ln>
+            <a:noFill/>
+          </a:ln>
+          <a:effectLst/>
+        </p:spPr>
+        <p:style>
+          <a:lnRef idx="1">
+            <a:schemeClr val="accent1"/>
+          </a:lnRef>
+          <a:fillRef idx="3">
+            <a:schemeClr val="accent1"/>
+          </a:fillRef>
+          <a:effectRef idx="2">
+            <a:schemeClr val="accent1"/>
+          </a:effectRef>
+          <a:fontRef idx="minor">
+            <a:schemeClr val="lt1"/>
+          </a:fontRef>
+        </p:style>
+        <p:txBody>
+          <a:bodyPr rtlCol="0" anchor="ctr" lIns="0" rIns="0" tIns="0" bIns="0"/>
+          <a:lstStyle/>
+          <a:p>
+            <a:pPr algn="ctr"/>
+            <a:r>
+              <a:rPr sz="1600" b="1" i="0">
+                <a:solidFill>
+                  <a:srgbClr val="FFFFFF"/>
+                </a:solidFill>
+                <a:latin typeface="Cambria"/>
+              </a:rPr>
+              <a:t>1</a:t>
+            </a:r>
+          </a:p>
+        </p:txBody>
+      </p:sp>
+      <p:sp>
+        <p:nvSpPr>
+          <p:cNvPr id="7" name="TextBox 6"/>
           <p:cNvSpPr txBox="1"/>
           <p:nvPr/>
         </p:nvSpPr>
         <p:spPr>
           <a:xfrm>
-            <a:off x="8412480" y="1600200"/>
-            <a:ext cx="3230575" cy="4754880"/>
+            <a:off x="8778240" y="1508760"/>
+            <a:ext cx="2864815" cy="365760"/>
           </a:xfrm>
           <a:prstGeom prst="rect">
             <a:avLst/>
@@ -8639,145 +8518,308 @@
           <a:noFill/>
         </p:spPr>
         <p:txBody>
-          <a:bodyPr wrap="square" lIns="0" rIns="0" tIns="0" bIns="0">
+          <a:bodyPr wrap="square" anchor="t" lIns="0" rIns="0" tIns="0" bIns="0">
             <a:spAutoFit/>
           </a:bodyPr>
           <a:lstStyle/>
           <a:p>
-            <a:pPr marL="256032" indent="-219456">
-              <a:spcAft>
-                <a:spcPts val="800"/>
-              </a:spcAft>
-              <a:buChar char="•"/>
-            </a:pPr>
-            <a:r>
-              <a:rPr sz="1500" b="1" i="0">
+            <a:pPr algn="l"/>
+            <a:r>
+              <a:rPr sz="1600" b="1" i="0">
                 <a:solidFill>
                   <a:srgbClr val="1B263B"/>
                 </a:solidFill>
                 <a:latin typeface="Calibri"/>
               </a:rPr>
-              <a:t>GPM: </a:t>
-            </a:r>
-            <a:r>
-              <a:rPr sz="1500" b="0" i="0">
+              <a:t>Task-agnostic item encoder</a:t>
+            </a:r>
+          </a:p>
+        </p:txBody>
+      </p:sp>
+      <p:sp>
+        <p:nvSpPr>
+          <p:cNvPr id="8" name="TextBox 7"/>
+          <p:cNvSpPr txBox="1"/>
+          <p:nvPr/>
+        </p:nvSpPr>
+        <p:spPr>
+          <a:xfrm>
+            <a:off x="8778240" y="1892808"/>
+            <a:ext cx="2864815" cy="1097280"/>
+          </a:xfrm>
+          <a:prstGeom prst="rect">
+            <a:avLst/>
+          </a:prstGeom>
+          <a:noFill/>
+        </p:spPr>
+        <p:txBody>
+          <a:bodyPr wrap="square" anchor="t" lIns="0" rIns="0" tIns="0" bIns="0">
+            <a:spAutoFit/>
+          </a:bodyPr>
+          <a:lstStyle/>
+          <a:p>
+            <a:pPr algn="l"/>
+            <a:r>
+              <a:rPr sz="1400" b="0" i="0">
                 <a:solidFill>
                   <a:srgbClr val="1B263B"/>
                 </a:solidFill>
                 <a:latin typeface="Calibri"/>
               </a:rPr>
-              <a:t>LightGCN on the full user–news graph → long-term embeddings e_g</a:t>
-            </a:r>
-          </a:p>
-          <a:p>
-            <a:pPr marL="256032" indent="-219456">
-              <a:spcAft>
-                <a:spcPts val="800"/>
-              </a:spcAft>
-              <a:buChar char="•"/>
-            </a:pPr>
-            <a:r>
-              <a:rPr sz="1500" b="1" i="0">
+              <a:t>T5 instruction-tuned on next-item prediction across datasets, using item text only (no IDs)</a:t>
+            </a:r>
+          </a:p>
+        </p:txBody>
+      </p:sp>
+      <p:sp>
+        <p:nvSpPr>
+          <p:cNvPr id="9" name="Oval 8"/>
+          <p:cNvSpPr/>
+          <p:nvPr/>
+        </p:nvSpPr>
+        <p:spPr>
+          <a:xfrm>
+            <a:off x="8138160" y="3108960"/>
+            <a:ext cx="457200" cy="457200"/>
+          </a:xfrm>
+          <a:prstGeom prst="ellipse">
+            <a:avLst/>
+          </a:prstGeom>
+          <a:solidFill>
+            <a:srgbClr val="3D6B73"/>
+          </a:solidFill>
+          <a:ln>
+            <a:noFill/>
+          </a:ln>
+          <a:effectLst/>
+        </p:spPr>
+        <p:style>
+          <a:lnRef idx="1">
+            <a:schemeClr val="accent1"/>
+          </a:lnRef>
+          <a:fillRef idx="3">
+            <a:schemeClr val="accent1"/>
+          </a:fillRef>
+          <a:effectRef idx="2">
+            <a:schemeClr val="accent1"/>
+          </a:effectRef>
+          <a:fontRef idx="minor">
+            <a:schemeClr val="lt1"/>
+          </a:fontRef>
+        </p:style>
+        <p:txBody>
+          <a:bodyPr rtlCol="0" anchor="ctr" lIns="0" rIns="0" tIns="0" bIns="0"/>
+          <a:lstStyle/>
+          <a:p>
+            <a:pPr algn="ctr"/>
+            <a:r>
+              <a:rPr sz="1600" b="1" i="0">
+                <a:solidFill>
+                  <a:srgbClr val="FFFFFF"/>
+                </a:solidFill>
+                <a:latin typeface="Cambria"/>
+              </a:rPr>
+              <a:t>2</a:t>
+            </a:r>
+          </a:p>
+        </p:txBody>
+      </p:sp>
+      <p:sp>
+        <p:nvSpPr>
+          <p:cNvPr id="10" name="TextBox 9"/>
+          <p:cNvSpPr txBox="1"/>
+          <p:nvPr/>
+        </p:nvSpPr>
+        <p:spPr>
+          <a:xfrm>
+            <a:off x="8778240" y="3108960"/>
+            <a:ext cx="2864815" cy="365760"/>
+          </a:xfrm>
+          <a:prstGeom prst="rect">
+            <a:avLst/>
+          </a:prstGeom>
+          <a:noFill/>
+        </p:spPr>
+        <p:txBody>
+          <a:bodyPr wrap="square" anchor="t" lIns="0" rIns="0" tIns="0" bIns="0">
+            <a:spAutoFit/>
+          </a:bodyPr>
+          <a:lstStyle/>
+          <a:p>
+            <a:pPr algn="l"/>
+            <a:r>
+              <a:rPr sz="1600" b="1" i="0">
                 <a:solidFill>
                   <a:srgbClr val="1B263B"/>
                 </a:solidFill>
                 <a:latin typeface="Calibri"/>
               </a:rPr>
-              <a:t>Temporal subgraphs: </a:t>
-            </a:r>
-            <a:r>
-              <a:rPr sz="1500" b="0" i="0">
+              <a:t>Personal item graph</a:t>
+            </a:r>
+          </a:p>
+        </p:txBody>
+      </p:sp>
+      <p:sp>
+        <p:nvSpPr>
+          <p:cNvPr id="11" name="TextBox 10"/>
+          <p:cNvSpPr txBox="1"/>
+          <p:nvPr/>
+        </p:nvSpPr>
+        <p:spPr>
+          <a:xfrm>
+            <a:off x="8778240" y="3493008"/>
+            <a:ext cx="2864815" cy="1097280"/>
+          </a:xfrm>
+          <a:prstGeom prst="rect">
+            <a:avLst/>
+          </a:prstGeom>
+          <a:noFill/>
+        </p:spPr>
+        <p:txBody>
+          <a:bodyPr wrap="square" anchor="t" lIns="0" rIns="0" tIns="0" bIns="0">
+            <a:spAutoFit/>
+          </a:bodyPr>
+          <a:lstStyle/>
+          <a:p>
+            <a:pPr algn="l"/>
+            <a:r>
+              <a:rPr sz="1400" b="0" i="0">
                 <a:solidFill>
                   <a:srgbClr val="1B263B"/>
                 </a:solidFill>
                 <a:latin typeface="Calibri"/>
               </a:rPr>
-              <a:t>split clicks into T windows (e.g. 2 weeks), one subgraph G_t each</a:t>
-            </a:r>
-          </a:p>
-          <a:p>
-            <a:pPr marL="256032" indent="-219456">
-              <a:spcAft>
-                <a:spcPts val="800"/>
-              </a:spcAft>
-              <a:buChar char="•"/>
-            </a:pPr>
-            <a:r>
-              <a:rPr sz="1500" b="1" i="0">
+              <a:t>Edge between two clicked items if cos(vi, vj) ≥ τ (τ = 0.7)</a:t>
+            </a:r>
+          </a:p>
+        </p:txBody>
+      </p:sp>
+      <p:sp>
+        <p:nvSpPr>
+          <p:cNvPr id="12" name="Oval 11"/>
+          <p:cNvSpPr/>
+          <p:nvPr/>
+        </p:nvSpPr>
+        <p:spPr>
+          <a:xfrm>
+            <a:off x="8138160" y="4709160"/>
+            <a:ext cx="457200" cy="457200"/>
+          </a:xfrm>
+          <a:prstGeom prst="ellipse">
+            <a:avLst/>
+          </a:prstGeom>
+          <a:solidFill>
+            <a:srgbClr val="3D6B73"/>
+          </a:solidFill>
+          <a:ln>
+            <a:noFill/>
+          </a:ln>
+          <a:effectLst/>
+        </p:spPr>
+        <p:style>
+          <a:lnRef idx="1">
+            <a:schemeClr val="accent1"/>
+          </a:lnRef>
+          <a:fillRef idx="3">
+            <a:schemeClr val="accent1"/>
+          </a:fillRef>
+          <a:effectRef idx="2">
+            <a:schemeClr val="accent1"/>
+          </a:effectRef>
+          <a:fontRef idx="minor">
+            <a:schemeClr val="lt1"/>
+          </a:fontRef>
+        </p:style>
+        <p:txBody>
+          <a:bodyPr rtlCol="0" anchor="ctr" lIns="0" rIns="0" tIns="0" bIns="0"/>
+          <a:lstStyle/>
+          <a:p>
+            <a:pPr algn="ctr"/>
+            <a:r>
+              <a:rPr sz="1600" b="1" i="0">
+                <a:solidFill>
+                  <a:srgbClr val="FFFFFF"/>
+                </a:solidFill>
+                <a:latin typeface="Cambria"/>
+              </a:rPr>
+              <a:t>3</a:t>
+            </a:r>
+          </a:p>
+        </p:txBody>
+      </p:sp>
+      <p:sp>
+        <p:nvSpPr>
+          <p:cNvPr id="13" name="TextBox 12"/>
+          <p:cNvSpPr txBox="1"/>
+          <p:nvPr/>
+        </p:nvSpPr>
+        <p:spPr>
+          <a:xfrm>
+            <a:off x="8778240" y="4709160"/>
+            <a:ext cx="2864815" cy="365760"/>
+          </a:xfrm>
+          <a:prstGeom prst="rect">
+            <a:avLst/>
+          </a:prstGeom>
+          <a:noFill/>
+        </p:spPr>
+        <p:txBody>
+          <a:bodyPr wrap="square" anchor="t" lIns="0" rIns="0" tIns="0" bIns="0">
+            <a:spAutoFit/>
+          </a:bodyPr>
+          <a:lstStyle/>
+          <a:p>
+            <a:pPr algn="l"/>
+            <a:r>
+              <a:rPr sz="1600" b="1" i="0">
                 <a:solidFill>
                   <a:srgbClr val="1B263B"/>
                 </a:solidFill>
                 <a:latin typeface="Calibri"/>
               </a:rPr>
-              <a:t>Short-term branch: </a:t>
-            </a:r>
-            <a:r>
-              <a:rPr sz="1500" b="0" i="0">
+              <a:t>Shortcut = largest component</a:t>
+            </a:r>
+          </a:p>
+        </p:txBody>
+      </p:sp>
+      <p:sp>
+        <p:nvSpPr>
+          <p:cNvPr id="14" name="TextBox 13"/>
+          <p:cNvSpPr txBox="1"/>
+          <p:nvPr/>
+        </p:nvSpPr>
+        <p:spPr>
+          <a:xfrm>
+            <a:off x="8778240" y="5093208"/>
+            <a:ext cx="2864815" cy="1097280"/>
+          </a:xfrm>
+          <a:prstGeom prst="rect">
+            <a:avLst/>
+          </a:prstGeom>
+          <a:noFill/>
+        </p:spPr>
+        <p:txBody>
+          <a:bodyPr wrap="square" anchor="t" lIns="0" rIns="0" tIns="0" bIns="0">
+            <a:spAutoFit/>
+          </a:bodyPr>
+          <a:lstStyle/>
+          <a:p>
+            <a:pPr algn="l"/>
+            <a:r>
+              <a:rPr sz="1400" b="0" i="0">
                 <a:solidFill>
                   <a:srgbClr val="1B263B"/>
                 </a:solidFill>
                 <a:latin typeface="Calibri"/>
               </a:rPr>
-              <a:t>GCN on each G_t (initialised by e_g) + LSTM across stages</a:t>
-            </a:r>
-          </a:p>
-          <a:p>
-            <a:pPr marL="256032" indent="-219456">
-              <a:spcAft>
-                <a:spcPts val="800"/>
-              </a:spcAft>
-              <a:buChar char="•"/>
-            </a:pPr>
-            <a:r>
-              <a:rPr sz="1500" b="1" i="0">
-                <a:solidFill>
-                  <a:srgbClr val="1B263B"/>
-                </a:solidFill>
-                <a:latin typeface="Calibri"/>
-              </a:rPr>
-              <a:t>Long-range branch: </a:t>
-            </a:r>
-            <a:r>
-              <a:rPr sz="1500" b="0" i="0">
-                <a:solidFill>
-                  <a:srgbClr val="1B263B"/>
-                </a:solidFill>
-                <a:latin typeface="Calibri"/>
-              </a:rPr>
-              <a:t>self-attention over all clicks up to stage t + position embedding</a:t>
-            </a:r>
-          </a:p>
-          <a:p>
-            <a:pPr marL="256032" indent="-219456">
-              <a:spcAft>
-                <a:spcPts val="800"/>
-              </a:spcAft>
-              <a:buChar char="•"/>
-            </a:pPr>
-            <a:r>
-              <a:rPr sz="1500" b="1" i="0">
-                <a:solidFill>
-                  <a:srgbClr val="1B263B"/>
-                </a:solidFill>
-                <a:latin typeface="Calibri"/>
-              </a:rPr>
-              <a:t>Fusion: </a:t>
-            </a:r>
-            <a:r>
-              <a:rPr sz="1500" b="0" i="0">
-                <a:solidFill>
-                  <a:srgbClr val="1B263B"/>
-                </a:solidFill>
-                <a:latin typeface="Calibri"/>
-              </a:rPr>
-              <a:t>user = short-term + long-range + global; score = σ(u·i)</a:t>
-            </a:r>
-          </a:p>
-        </p:txBody>
-      </p:sp>
-      <p:sp>
-        <p:nvSpPr>
-          <p:cNvPr id="7" name="TextBox 6"/>
+              <a:t>Its items become the denoised history fed to the recommender (TASTE / BERT4Rec)</a:t>
+            </a:r>
+          </a:p>
+        </p:txBody>
+      </p:sp>
+      <p:sp>
+        <p:nvSpPr>
+          <p:cNvPr id="15" name="TextBox 14"/>
           <p:cNvSpPr txBox="1"/>
           <p:nvPr/>
         </p:nvSpPr>
@@ -8919,57 +8961,40 @@
                 </a:solidFill>
                 <a:latin typeface="Cambria"/>
               </a:rPr>
-              <a:t>Training: one prediction loss, two regularisers</a:t>
-            </a:r>
-          </a:p>
-        </p:txBody>
-      </p:sp>
-      <p:sp>
-        <p:nvSpPr>
-          <p:cNvPr id="4" name="Rounded Rectangle 3"/>
-          <p:cNvSpPr/>
-          <p:nvPr/>
-        </p:nvSpPr>
-        <p:spPr>
-          <a:xfrm>
-            <a:off x="548640" y="1600200"/>
-            <a:ext cx="3515258" cy="1874519"/>
-          </a:xfrm>
-          <a:prstGeom prst="roundRect">
-            <a:avLst>
-              <a:gd name="adj" fmla="val 8000"/>
-            </a:avLst>
-          </a:prstGeom>
-          <a:solidFill>
-            <a:srgbClr val="F2F3F5"/>
-          </a:solidFill>
-          <a:ln>
-            <a:noFill/>
+              <a:t>Case study: the perfume that does not belong</a:t>
+            </a:r>
+          </a:p>
+        </p:txBody>
+      </p:sp>
+      <p:pic>
+        <p:nvPicPr>
+          <p:cNvPr id="4" name="Picture 3" descr="a_tab5_case.png"/>
+          <p:cNvPicPr>
+            <a:picLocks noChangeAspect="1"/>
+          </p:cNvPicPr>
+          <p:nvPr/>
+        </p:nvPicPr>
+        <p:blipFill>
+          <a:blip r:embed="rId2"/>
+          <a:stretch>
+            <a:fillRect/>
+          </a:stretch>
+        </p:blipFill>
+        <p:spPr>
+          <a:xfrm>
+            <a:off x="548640" y="1750664"/>
+            <a:ext cx="7680960" cy="3219512"/>
+          </a:xfrm>
+          <a:prstGeom prst="rect">
+            <a:avLst/>
+          </a:prstGeom>
+          <a:ln w="9525">
+            <a:solidFill>
+              <a:srgbClr val="D5DAE1"/>
+            </a:solidFill>
           </a:ln>
-          <a:effectLst/>
-        </p:spPr>
-        <p:style>
-          <a:lnRef idx="1">
-            <a:schemeClr val="accent1"/>
-          </a:lnRef>
-          <a:fillRef idx="3">
-            <a:schemeClr val="accent1"/>
-          </a:fillRef>
-          <a:effectRef idx="2">
-            <a:schemeClr val="accent1"/>
-          </a:effectRef>
-          <a:fontRef idx="minor">
-            <a:schemeClr val="lt1"/>
-          </a:fontRef>
-        </p:style>
-        <p:txBody>
-          <a:bodyPr rtlCol="0" anchor="ctr"/>
-          <a:lstStyle/>
-          <a:p>
-            <a:pPr algn="ctr"/>
-          </a:p>
-        </p:txBody>
-      </p:sp>
+        </p:spPr>
+      </p:pic>
       <p:sp>
         <p:nvSpPr>
           <p:cNvPr id="5" name="TextBox 4"/>
@@ -8978,8 +9003,8 @@
         </p:nvSpPr>
         <p:spPr>
           <a:xfrm>
-            <a:off x="777240" y="1783080"/>
-            <a:ext cx="3058058" cy="411480"/>
+            <a:off x="548640" y="5043328"/>
+            <a:ext cx="7680960" cy="274320"/>
           </a:xfrm>
           <a:prstGeom prst="rect">
             <a:avLst/>
@@ -8992,15 +9017,15 @@
           </a:bodyPr>
           <a:lstStyle/>
           <a:p>
-            <a:pPr algn="l"/>
-            <a:r>
-              <a:rPr sz="1800" b="1" i="0">
-                <a:solidFill>
-                  <a:srgbClr val="3D6B73"/>
-                </a:solidFill>
-                <a:latin typeface="Cambria"/>
-              </a:rPr>
-              <a:t>Prediction  (λt = 0.1)</a:t>
+            <a:pPr algn="ctr"/>
+            <a:r>
+              <a:rPr sz="1100" b="0" i="1">
+                <a:solidFill>
+                  <a:srgbClr val="5B677A"/>
+                </a:solidFill>
+                <a:latin typeface="Calibri"/>
+              </a:rPr>
+              <a:t>Table 5 of Paper A: Amazon Beauty case</a:t>
             </a:r>
           </a:p>
         </p:txBody>
@@ -9013,310 +9038,8 @@
         </p:nvSpPr>
         <p:spPr>
           <a:xfrm>
-            <a:off x="777240" y="2240280"/>
-            <a:ext cx="3058058" cy="1142999"/>
-          </a:xfrm>
-          <a:prstGeom prst="rect">
-            <a:avLst/>
-          </a:prstGeom>
-          <a:noFill/>
-        </p:spPr>
-        <p:txBody>
-          <a:bodyPr wrap="square" anchor="t" lIns="0" rIns="0" tIns="0" bIns="0">
-            <a:spAutoFit/>
-          </a:bodyPr>
-          <a:lstStyle/>
-          <a:p>
-            <a:pPr algn="l"/>
-            <a:r>
-              <a:rPr sz="1500" b="0" i="0">
-                <a:solidFill>
-                  <a:srgbClr val="1B263B"/>
-                </a:solidFill>
-                <a:latin typeface="Calibri"/>
-              </a:rPr>
-              <a:t>Binary cross-entropy on clicks inside each time segment, with 4 sampled negatives per positive click.</a:t>
-            </a:r>
-          </a:p>
-        </p:txBody>
-      </p:sp>
-      <p:sp>
-        <p:nvSpPr>
-          <p:cNvPr id="7" name="Rounded Rectangle 6"/>
-          <p:cNvSpPr/>
-          <p:nvPr/>
-        </p:nvSpPr>
-        <p:spPr>
-          <a:xfrm>
-            <a:off x="4338218" y="1600200"/>
-            <a:ext cx="3515258" cy="1874519"/>
-          </a:xfrm>
-          <a:prstGeom prst="roundRect">
-            <a:avLst>
-              <a:gd name="adj" fmla="val 8000"/>
-            </a:avLst>
-          </a:prstGeom>
-          <a:solidFill>
-            <a:srgbClr val="F2F3F5"/>
-          </a:solidFill>
-          <a:ln>
-            <a:noFill/>
-          </a:ln>
-          <a:effectLst/>
-        </p:spPr>
-        <p:style>
-          <a:lnRef idx="1">
-            <a:schemeClr val="accent1"/>
-          </a:lnRef>
-          <a:fillRef idx="3">
-            <a:schemeClr val="accent1"/>
-          </a:fillRef>
-          <a:effectRef idx="2">
-            <a:schemeClr val="accent1"/>
-          </a:effectRef>
-          <a:fontRef idx="minor">
-            <a:schemeClr val="lt1"/>
-          </a:fontRef>
-        </p:style>
-        <p:txBody>
-          <a:bodyPr rtlCol="0" anchor="ctr"/>
-          <a:lstStyle/>
-          <a:p>
-            <a:pPr algn="ctr"/>
-          </a:p>
-        </p:txBody>
-      </p:sp>
-      <p:sp>
-        <p:nvSpPr>
-          <p:cNvPr id="8" name="TextBox 7"/>
-          <p:cNvSpPr txBox="1"/>
-          <p:nvPr/>
-        </p:nvSpPr>
-        <p:spPr>
-          <a:xfrm>
-            <a:off x="4566818" y="1783080"/>
-            <a:ext cx="3058058" cy="411480"/>
-          </a:xfrm>
-          <a:prstGeom prst="rect">
-            <a:avLst/>
-          </a:prstGeom>
-          <a:noFill/>
-        </p:spPr>
-        <p:txBody>
-          <a:bodyPr wrap="square" anchor="t" lIns="0" rIns="0" tIns="0" bIns="0">
-            <a:spAutoFit/>
-          </a:bodyPr>
-          <a:lstStyle/>
-          <a:p>
-            <a:pPr algn="l"/>
-            <a:r>
-              <a:rPr sz="1800" b="1" i="0">
-                <a:solidFill>
-                  <a:srgbClr val="3D6B73"/>
-                </a:solidFill>
-                <a:latin typeface="Cambria"/>
-              </a:rPr>
-              <a:t>Consistency  (λcl = 0.01)</a:t>
-            </a:r>
-          </a:p>
-        </p:txBody>
-      </p:sp>
-      <p:sp>
-        <p:nvSpPr>
-          <p:cNvPr id="9" name="TextBox 8"/>
-          <p:cNvSpPr txBox="1"/>
-          <p:nvPr/>
-        </p:nvSpPr>
-        <p:spPr>
-          <a:xfrm>
-            <a:off x="4566818" y="2240280"/>
-            <a:ext cx="3058058" cy="1142999"/>
-          </a:xfrm>
-          <a:prstGeom prst="rect">
-            <a:avLst/>
-          </a:prstGeom>
-          <a:noFill/>
-        </p:spPr>
-        <p:txBody>
-          <a:bodyPr wrap="square" anchor="t" lIns="0" rIns="0" tIns="0" bIns="0">
-            <a:spAutoFit/>
-          </a:bodyPr>
-          <a:lstStyle/>
-          <a:p>
-            <a:pPr algn="l"/>
-            <a:r>
-              <a:rPr sz="1500" b="0" i="0">
-                <a:solidFill>
-                  <a:srgbClr val="1B263B"/>
-                </a:solidFill>
-                <a:latin typeface="Calibri"/>
-              </a:rPr>
-              <a:t>Contrastive (InfoNCE, τ = 0.1): a user's stage embedding should stay close to their own global embedding and far from other users'.</a:t>
-            </a:r>
-          </a:p>
-        </p:txBody>
-      </p:sp>
-      <p:sp>
-        <p:nvSpPr>
-          <p:cNvPr id="10" name="Rounded Rectangle 9"/>
-          <p:cNvSpPr/>
-          <p:nvPr/>
-        </p:nvSpPr>
-        <p:spPr>
-          <a:xfrm>
-            <a:off x="8127796" y="1600200"/>
-            <a:ext cx="3515258" cy="1874519"/>
-          </a:xfrm>
-          <a:prstGeom prst="roundRect">
-            <a:avLst>
-              <a:gd name="adj" fmla="val 8000"/>
-            </a:avLst>
-          </a:prstGeom>
-          <a:solidFill>
-            <a:srgbClr val="F2F3F5"/>
-          </a:solidFill>
-          <a:ln>
-            <a:noFill/>
-          </a:ln>
-          <a:effectLst/>
-        </p:spPr>
-        <p:style>
-          <a:lnRef idx="1">
-            <a:schemeClr val="accent1"/>
-          </a:lnRef>
-          <a:fillRef idx="3">
-            <a:schemeClr val="accent1"/>
-          </a:fillRef>
-          <a:effectRef idx="2">
-            <a:schemeClr val="accent1"/>
-          </a:effectRef>
-          <a:fontRef idx="minor">
-            <a:schemeClr val="lt1"/>
-          </a:fontRef>
-        </p:style>
-        <p:txBody>
-          <a:bodyPr rtlCol="0" anchor="ctr"/>
-          <a:lstStyle/>
-          <a:p>
-            <a:pPr algn="ctr"/>
-          </a:p>
-        </p:txBody>
-      </p:sp>
-      <p:sp>
-        <p:nvSpPr>
-          <p:cNvPr id="11" name="TextBox 10"/>
-          <p:cNvSpPr txBox="1"/>
-          <p:nvPr/>
-        </p:nvSpPr>
-        <p:spPr>
-          <a:xfrm>
-            <a:off x="8356396" y="1783080"/>
-            <a:ext cx="3058058" cy="411480"/>
-          </a:xfrm>
-          <a:prstGeom prst="rect">
-            <a:avLst/>
-          </a:prstGeom>
-          <a:noFill/>
-        </p:spPr>
-        <p:txBody>
-          <a:bodyPr wrap="square" anchor="t" lIns="0" rIns="0" tIns="0" bIns="0">
-            <a:spAutoFit/>
-          </a:bodyPr>
-          <a:lstStyle/>
-          <a:p>
-            <a:pPr algn="l"/>
-            <a:r>
-              <a:rPr sz="1800" b="1" i="0">
-                <a:solidFill>
-                  <a:srgbClr val="3D6B73"/>
-                </a:solidFill>
-                <a:latin typeface="Cambria"/>
-              </a:rPr>
-              <a:t>Smoothness  (λsl = 0.01)</a:t>
-            </a:r>
-          </a:p>
-        </p:txBody>
-      </p:sp>
-      <p:sp>
-        <p:nvSpPr>
-          <p:cNvPr id="12" name="TextBox 11"/>
-          <p:cNvSpPr txBox="1"/>
-          <p:nvPr/>
-        </p:nvSpPr>
-        <p:spPr>
-          <a:xfrm>
-            <a:off x="8356396" y="2240280"/>
-            <a:ext cx="3058058" cy="1142999"/>
-          </a:xfrm>
-          <a:prstGeom prst="rect">
-            <a:avLst/>
-          </a:prstGeom>
-          <a:noFill/>
-        </p:spPr>
-        <p:txBody>
-          <a:bodyPr wrap="square" anchor="t" lIns="0" rIns="0" tIns="0" bIns="0">
-            <a:spAutoFit/>
-          </a:bodyPr>
-          <a:lstStyle/>
-          <a:p>
-            <a:pPr algn="l"/>
-            <a:r>
-              <a:rPr sz="1500" b="0" i="0">
-                <a:solidFill>
-                  <a:srgbClr val="1B263B"/>
-                </a:solidFill>
-                <a:latin typeface="Calibri"/>
-              </a:rPr>
-              <a:t>‖e_u^t − e_u^(t−1)‖² keeps adjacent stages close: interests drift gradually, not abruptly.</a:t>
-            </a:r>
-          </a:p>
-        </p:txBody>
-      </p:sp>
-      <p:sp>
-        <p:nvSpPr>
-          <p:cNvPr id="13" name="TextBox 12"/>
-          <p:cNvSpPr txBox="1"/>
-          <p:nvPr/>
-        </p:nvSpPr>
-        <p:spPr>
-          <a:xfrm>
-            <a:off x="548640" y="3886200"/>
-            <a:ext cx="11094415" cy="548640"/>
-          </a:xfrm>
-          <a:prstGeom prst="rect">
-            <a:avLst/>
-          </a:prstGeom>
-          <a:noFill/>
-        </p:spPr>
-        <p:txBody>
-          <a:bodyPr wrap="square" anchor="t" lIns="0" rIns="0" tIns="0" bIns="0">
-            <a:spAutoFit/>
-          </a:bodyPr>
-          <a:lstStyle/>
-          <a:p>
-            <a:pPr algn="ctr"/>
-            <a:r>
-              <a:rPr sz="2400" b="1" i="0">
-                <a:solidFill>
-                  <a:srgbClr val="1B263B"/>
-                </a:solidFill>
-                <a:latin typeface="Cambria"/>
-              </a:rPr>
-              <a:t>L  =  Σt λt·Lt  +  λcl·Lcl  +  λsl·Lsl  +  β‖Θ‖²</a:t>
-            </a:r>
-          </a:p>
-        </p:txBody>
-      </p:sp>
-      <p:sp>
-        <p:nvSpPr>
-          <p:cNvPr id="14" name="TextBox 13"/>
-          <p:cNvSpPr txBox="1"/>
-          <p:nvPr/>
-        </p:nvSpPr>
-        <p:spPr>
-          <a:xfrm>
-            <a:off x="548640" y="4800600"/>
-            <a:ext cx="11094415" cy="1463040"/>
+            <a:off x="8503919" y="1600200"/>
+            <a:ext cx="3139136" cy="4206240"/>
           </a:xfrm>
           <a:prstGeom prst="rect">
             <a:avLst/>
@@ -9336,22 +9059,13 @@
               <a:buChar char="•"/>
             </a:pPr>
             <a:r>
-              <a:rPr sz="1500" b="1" i="0">
+              <a:rPr sz="1500" b="0" i="0">
                 <a:solidFill>
                   <a:srgbClr val="1B263B"/>
                 </a:solidFill>
                 <a:latin typeface="Calibri"/>
               </a:rPr>
-              <a:t>Datasets: </a:t>
-            </a:r>
-            <a:r>
-              <a:rPr sz="1500" b="0" i="0">
-                <a:solidFill>
-                  <a:srgbClr val="1B263B"/>
-                </a:solidFill>
-                <a:latin typeface="Calibri"/>
-              </a:rPr>
-              <a:t>Adressa-large (3.6M users, 35M clicks, 3 months) and MIND-large (1M users, 24M clicks, 6 weeks)</a:t>
+              <a:t>n1, n2, n4 are moisturisers; pairwise similarity ≈ 0.44–0.46</a:t>
             </a:r>
           </a:p>
           <a:p>
@@ -9368,7 +9082,7 @@
                 </a:solidFill>
                 <a:latin typeface="Calibri"/>
               </a:rPr>
-              <a:t>Metrics: </a:t>
+              <a:t>n3 is a perfume: </a:t>
             </a:r>
             <a:r>
               <a:rPr sz="1500" b="0" i="0">
@@ -9377,14 +9091,92 @@
                 </a:solidFill>
                 <a:latin typeface="Calibri"/>
               </a:rPr>
-              <a:t>AUC, MRR, nDCG@5/10 against 7 baselines (NRMS, NAML, NPA, LightGCN, CNE-SUE, TCCM, CROWN)</a:t>
-            </a:r>
-          </a:p>
-        </p:txBody>
-      </p:sp>
-      <p:sp>
-        <p:nvSpPr>
-          <p:cNvPr id="15" name="TextBox 14"/>
+              <a:t>similarity to the rest only 0.20–0.25</a:t>
+            </a:r>
+          </a:p>
+          <a:p>
+            <a:pPr marL="256032" indent="-219456">
+              <a:spcAft>
+                <a:spcPts val="800"/>
+              </a:spcAft>
+              <a:buChar char="•"/>
+            </a:pPr>
+            <a:r>
+              <a:rPr sz="1500" b="0" i="0">
+                <a:solidFill>
+                  <a:srgbClr val="1B263B"/>
+                </a:solidFill>
+                <a:latin typeface="Calibri"/>
+              </a:rPr>
+              <a:t>No edge reaches n3 → shortcut = {1, 2, 4}</a:t>
+            </a:r>
+          </a:p>
+          <a:p>
+            <a:pPr marL="256032" indent="-219456">
+              <a:spcAft>
+                <a:spcPts val="800"/>
+              </a:spcAft>
+              <a:buChar char="•"/>
+            </a:pPr>
+            <a:r>
+              <a:rPr sz="1500" b="1" i="0">
+                <a:solidFill>
+                  <a:srgbClr val="1B263B"/>
+                </a:solidFill>
+                <a:latin typeface="Calibri"/>
+              </a:rPr>
+              <a:t>Yelp case: </a:t>
+            </a:r>
+            <a:r>
+              <a:rPr sz="1500" b="0" i="0">
+                <a:solidFill>
+                  <a:srgbClr val="1B263B"/>
+                </a:solidFill>
+                <a:latin typeface="Calibri"/>
+              </a:rPr>
+              <a:t>a vet clinic among bars &amp; restaurants is dropped the same way</a:t>
+            </a:r>
+          </a:p>
+        </p:txBody>
+      </p:sp>
+      <p:sp>
+        <p:nvSpPr>
+          <p:cNvPr id="7" name="TextBox 6"/>
+          <p:cNvSpPr txBox="1"/>
+          <p:nvPr/>
+        </p:nvSpPr>
+        <p:spPr>
+          <a:xfrm>
+            <a:off x="548640" y="5760720"/>
+            <a:ext cx="11094415" cy="457200"/>
+          </a:xfrm>
+          <a:prstGeom prst="rect">
+            <a:avLst/>
+          </a:prstGeom>
+          <a:noFill/>
+        </p:spPr>
+        <p:txBody>
+          <a:bodyPr wrap="square" anchor="t" lIns="0" rIns="0" tIns="0" bIns="0">
+            <a:spAutoFit/>
+          </a:bodyPr>
+          <a:lstStyle/>
+          <a:p>
+            <a:pPr algn="l"/>
+            <a:r>
+              <a:rPr sz="1500" b="0" i="1">
+                <a:solidFill>
+                  <a:srgbClr val="1B263B"/>
+                </a:solidFill>
+                <a:latin typeface="Calibri"/>
+              </a:rPr>
+              <a:t>Explicit, inspectable denoising: you can see exactly which clicks were removed and why.</a:t>
+            </a:r>
+          </a:p>
+        </p:txBody>
+      </p:sp>
+      <p:sp>
+        <p:nvSpPr>
+          <p:cNvPr id="8" name="TextBox 7"/>
           <p:cNvSpPr txBox="1"/>
           <p:nvPr/>
         </p:nvSpPr>
@@ -9526,14 +9318,14 @@
                 </a:solidFill>
                 <a:latin typeface="Cambria"/>
               </a:rPr>
-              <a:t>Results: large gains, especially on Adressa</a:t>
+              <a:t>Results: consistent gains on four datasets</a:t>
             </a:r>
           </a:p>
         </p:txBody>
       </p:sp>
       <p:pic>
         <p:nvPicPr>
-          <p:cNvPr id="4" name="Picture 3" descr="a_tab2_results.png"/>
+          <p:cNvPr id="4" name="Picture 3" descr="a_tab1_results.png"/>
           <p:cNvPicPr>
             <a:picLocks noChangeAspect="1"/>
           </p:cNvPicPr>
@@ -9547,8 +9339,8 @@
         </p:blipFill>
         <p:spPr>
           <a:xfrm>
-            <a:off x="548640" y="1805858"/>
-            <a:ext cx="7498078" cy="1920403"/>
+            <a:off x="548640" y="1478971"/>
+            <a:ext cx="7680960" cy="2665617"/>
           </a:xfrm>
           <a:prstGeom prst="rect">
             <a:avLst/>
@@ -9568,8 +9360,8 @@
         </p:nvSpPr>
         <p:spPr>
           <a:xfrm>
-            <a:off x="548640" y="3799413"/>
-            <a:ext cx="7498079" cy="274320"/>
+            <a:off x="548640" y="4217740"/>
+            <a:ext cx="7680960" cy="274320"/>
           </a:xfrm>
           <a:prstGeom prst="rect">
             <a:avLst/>
@@ -9590,14 +9382,14 @@
                 </a:solidFill>
                 <a:latin typeface="Calibri"/>
               </a:rPr>
-              <a:t>Table 2 of Paper A: comparison with baselines</a:t>
+              <a:t>Table 1 of Paper A: overall performance (Recall / NDCG @10, @20)</a:t>
             </a:r>
           </a:p>
         </p:txBody>
       </p:sp>
       <p:pic>
         <p:nvPicPr>
-          <p:cNvPr id="6" name="Picture 5" descr="a_tab3_ablation.png"/>
+          <p:cNvPr id="6" name="Picture 5" descr="a_fig3_tau.png"/>
           <p:cNvPicPr>
             <a:picLocks noChangeAspect="1"/>
           </p:cNvPicPr>
@@ -9611,8 +9403,8 @@
         </p:blipFill>
         <p:spPr>
           <a:xfrm>
-            <a:off x="548640" y="4601718"/>
-            <a:ext cx="3657600" cy="1449324"/>
+            <a:off x="739100" y="4617720"/>
+            <a:ext cx="3368119" cy="1508760"/>
           </a:xfrm>
           <a:prstGeom prst="rect">
             <a:avLst/>
@@ -9632,8 +9424,8 @@
         </p:nvSpPr>
         <p:spPr>
           <a:xfrm>
-            <a:off x="548640" y="6124194"/>
-            <a:ext cx="3657600" cy="274320"/>
+            <a:off x="548640" y="6199632"/>
+            <a:ext cx="3749039" cy="274320"/>
           </a:xfrm>
           <a:prstGeom prst="rect">
             <a:avLst/>
@@ -9654,14 +9446,14 @@
                 </a:solidFill>
                 <a:latin typeface="Calibri"/>
               </a:rPr>
-              <a:t>Table 3: ablation (Adressa)</a:t>
+              <a:t>Figure 3: threshold τ sensitivity</a:t>
             </a:r>
           </a:p>
         </p:txBody>
       </p:sp>
       <p:pic>
         <p:nvPicPr>
-          <p:cNvPr id="8" name="Picture 7" descr="a_fig2_window.png"/>
+          <p:cNvPr id="8" name="Picture 7" descr="a_fig6_effect.png"/>
           <p:cNvPicPr>
             <a:picLocks noChangeAspect="1"/>
           </p:cNvPicPr>
@@ -9675,8 +9467,8 @@
         </p:blipFill>
         <p:spPr>
           <a:xfrm>
-            <a:off x="4389120" y="4658792"/>
-            <a:ext cx="3657600" cy="1335176"/>
+            <a:off x="4897063" y="4617720"/>
+            <a:ext cx="2916033" cy="1508760"/>
           </a:xfrm>
           <a:prstGeom prst="rect">
             <a:avLst/>
@@ -9696,8 +9488,8 @@
         </p:nvSpPr>
         <p:spPr>
           <a:xfrm>
-            <a:off x="4389120" y="6067120"/>
-            <a:ext cx="3657600" cy="274320"/>
+            <a:off x="4480560" y="6199632"/>
+            <a:ext cx="3749039" cy="274320"/>
           </a:xfrm>
           <a:prstGeom prst="rect">
             <a:avLst/>
@@ -9718,7 +9510,7 @@
                 </a:solidFill>
                 <a:latin typeface="Calibri"/>
               </a:rPr>
-              <a:t>Figure 2: window size</a:t>
+              <a:t>Figure 6: closer user–target, outliers pushed out</a:t>
             </a:r>
           </a:p>
         </p:txBody>
@@ -9731,8 +9523,8 @@
         </p:nvSpPr>
         <p:spPr>
           <a:xfrm>
-            <a:off x="8412480" y="1417320"/>
-            <a:ext cx="3230575" cy="777240"/>
+            <a:off x="8595360" y="1417320"/>
+            <a:ext cx="3047695" cy="777240"/>
           </a:xfrm>
           <a:prstGeom prst="rect">
             <a:avLst/>
@@ -9753,7 +9545,7 @@
                 </a:solidFill>
                 <a:latin typeface="Cambria"/>
               </a:rPr>
-              <a:t>0.80</a:t>
+              <a:t>+13%</a:t>
             </a:r>
           </a:p>
         </p:txBody>
@@ -9766,8 +9558,8 @@
         </p:nvSpPr>
         <p:spPr>
           <a:xfrm>
-            <a:off x="8412480" y="2194560"/>
-            <a:ext cx="3230575" cy="640080"/>
+            <a:off x="8595360" y="2194560"/>
+            <a:ext cx="3047695" cy="640080"/>
           </a:xfrm>
           <a:prstGeom prst="rect">
             <a:avLst/>
@@ -9788,7 +9580,7 @@
                 </a:solidFill>
                 <a:latin typeface="Calibri"/>
               </a:rPr>
-              <a:t>AUC on Adressa vs 0.66 for best baseline (CROWN)</a:t>
+              <a:t>best improvement over baselines (Beauty)</a:t>
             </a:r>
           </a:p>
         </p:txBody>
@@ -9801,8 +9593,8 @@
         </p:nvSpPr>
         <p:spPr>
           <a:xfrm>
-            <a:off x="8412480" y="2880360"/>
-            <a:ext cx="3230575" cy="777240"/>
+            <a:off x="8595360" y="2880360"/>
+            <a:ext cx="3047695" cy="777240"/>
           </a:xfrm>
           <a:prstGeom prst="rect">
             <a:avLst/>
@@ -9823,7 +9615,7 @@
                 </a:solidFill>
                 <a:latin typeface="Cambria"/>
               </a:rPr>
-              <a:t>0.58</a:t>
+              <a:t>+4.7%</a:t>
             </a:r>
           </a:p>
         </p:txBody>
@@ -9836,8 +9628,8 @@
         </p:nvSpPr>
         <p:spPr>
           <a:xfrm>
-            <a:off x="8412480" y="3657600"/>
-            <a:ext cx="3230575" cy="640080"/>
+            <a:off x="8595360" y="3657600"/>
+            <a:ext cx="3047695" cy="640080"/>
           </a:xfrm>
           <a:prstGeom prst="rect">
             <a:avLst/>
@@ -9858,7 +9650,7 @@
                 </a:solidFill>
                 <a:latin typeface="Calibri"/>
               </a:rPr>
-              <a:t>AUC on MIND vs 0.55 (smaller gain)</a:t>
+              <a:t>over denoising methods (DSAN, HSD, DCRec)</a:t>
             </a:r>
           </a:p>
         </p:txBody>
@@ -9871,8 +9663,8 @@
         </p:nvSpPr>
         <p:spPr>
           <a:xfrm>
-            <a:off x="8412480" y="4389120"/>
-            <a:ext cx="3230575" cy="2194560"/>
+            <a:off x="8595360" y="4389120"/>
+            <a:ext cx="3047695" cy="2194560"/>
           </a:xfrm>
           <a:prstGeom prst="rect">
             <a:avLst/>
@@ -9898,7 +9690,7 @@
                 </a:solidFill>
                 <a:latin typeface="Calibri"/>
               </a:rPr>
-              <a:t>Removing any module hurts a lot</a:t>
+              <a:t>Big gains on shopping data, small on Yelp</a:t>
             </a:r>
           </a:p>
           <a:p>
@@ -9909,22 +9701,13 @@
               <a:buChar char="•"/>
             </a:pPr>
             <a:r>
-              <a:rPr sz="1400" b="1" i="0">
+              <a:rPr sz="1400" b="0" i="0">
                 <a:solidFill>
                   <a:srgbClr val="1B263B"/>
                 </a:solidFill>
                 <a:latin typeface="Calibri"/>
               </a:rPr>
-              <a:t>2-week window is best: </a:t>
-            </a:r>
-            <a:r>
-              <a:rPr sz="1400" b="0" i="0">
-                <a:solidFill>
-                  <a:srgbClr val="1B263B"/>
-                </a:solidFill>
-                <a:latin typeface="Calibri"/>
-              </a:rPr>
-              <a:t>shorter = too sparse, longer = blurs shifts</a:t>
+              <a:t>Even a zero-shot filter helps</a:t>
             </a:r>
           </a:p>
         </p:txBody>
@@ -10073,7 +9856,7 @@
                 </a:solidFill>
                 <a:latin typeface="Cambria"/>
               </a:rPr>
-              <a:t>Not every click reflects a real preference</a:t>
+              <a:t>News interests are time-sensitive</a:t>
             </a:r>
           </a:p>
         </p:txBody>
@@ -10108,85 +9891,21 @@
                 </a:solidFill>
                 <a:latin typeface="Calibri"/>
               </a:rPr>
-              <a:t>LISRec: Modeling User Preferences with Learned Item Shortcuts · KDD '26</a:t>
-            </a:r>
-          </a:p>
-        </p:txBody>
-      </p:sp>
-      <p:pic>
-        <p:nvPicPr>
-          <p:cNvPr id="5" name="Picture 4" descr="b_fig1_idea.png"/>
-          <p:cNvPicPr>
-            <a:picLocks noChangeAspect="1"/>
-          </p:cNvPicPr>
-          <p:nvPr/>
-        </p:nvPicPr>
-        <p:blipFill>
-          <a:blip r:embed="rId2"/>
-          <a:stretch>
-            <a:fillRect/>
-          </a:stretch>
-        </p:blipFill>
-        <p:spPr>
-          <a:xfrm>
-            <a:off x="1247892" y="1417320"/>
-            <a:ext cx="3722135" cy="4617720"/>
-          </a:xfrm>
-          <a:prstGeom prst="rect">
-            <a:avLst/>
-          </a:prstGeom>
-          <a:ln w="9525">
-            <a:solidFill>
-              <a:srgbClr val="D5DAE1"/>
-            </a:solidFill>
-          </a:ln>
-        </p:spPr>
-      </p:pic>
-      <p:sp>
-        <p:nvSpPr>
-          <p:cNvPr id="6" name="TextBox 5"/>
+              <a:t>Modeling Stage-wise Evolution of User Interests for News Recommendation · WWW '26</a:t>
+            </a:r>
+          </a:p>
+        </p:txBody>
+      </p:sp>
+      <p:sp>
+        <p:nvSpPr>
+          <p:cNvPr id="5" name="TextBox 4"/>
           <p:cNvSpPr txBox="1"/>
           <p:nvPr/>
         </p:nvSpPr>
         <p:spPr>
           <a:xfrm>
-            <a:off x="548640" y="6108192"/>
-            <a:ext cx="5120640" cy="274320"/>
-          </a:xfrm>
-          <a:prstGeom prst="rect">
-            <a:avLst/>
-          </a:prstGeom>
-          <a:noFill/>
-        </p:spPr>
-        <p:txBody>
-          <a:bodyPr wrap="square" anchor="t" lIns="0" rIns="0" tIns="0" bIns="0">
-            <a:spAutoFit/>
-          </a:bodyPr>
-          <a:lstStyle/>
-          <a:p>
-            <a:pPr algn="ctr"/>
-            <a:r>
-              <a:rPr sz="1100" b="0" i="1">
-                <a:solidFill>
-                  <a:srgbClr val="5B677A"/>
-                </a:solidFill>
-                <a:latin typeface="Calibri"/>
-              </a:rPr>
-              <a:t>Figure 1 of Paper B: a LEGO fan clicks a Nintendo Switch</a:t>
-            </a:r>
-          </a:p>
-        </p:txBody>
-      </p:sp>
-      <p:sp>
-        <p:nvSpPr>
-          <p:cNvPr id="7" name="TextBox 6"/>
-          <p:cNvSpPr txBox="1"/>
-          <p:nvPr/>
-        </p:nvSpPr>
-        <p:spPr>
-          <a:xfrm>
-            <a:off x="6035040" y="1600200"/>
-            <a:ext cx="5608015" cy="3108960"/>
+            <a:off x="548640" y="1691640"/>
+            <a:ext cx="5760720" cy="4114800"/>
           </a:xfrm>
           <a:prstGeom prst="rect">
             <a:avLst/>
@@ -10206,22 +9925,22 @@
               <a:buChar char="•"/>
             </a:pPr>
             <a:r>
-              <a:rPr sz="1600" b="1" i="0">
+              <a:rPr sz="1700" b="1" i="0">
                 <a:solidFill>
                   <a:srgbClr val="1B263B"/>
                 </a:solidFill>
                 <a:latin typeface="Calibri"/>
               </a:rPr>
-              <a:t>Histories contain noise: </a:t>
-            </a:r>
-            <a:r>
-              <a:rPr sz="1600" b="0" i="0">
+              <a:t>News loses value fast: </a:t>
+            </a:r>
+            <a:r>
+              <a:rPr sz="1700" b="0" i="0">
                 <a:solidFill>
                   <a:srgbClr val="1B263B"/>
                 </a:solidFill>
                 <a:latin typeface="Calibri"/>
               </a:rPr>
-              <a:t>accidental clicks, momentary curiosity</a:t>
+              <a:t>users want the latest events, trending topics, seasonal contexts</a:t>
             </a:r>
           </a:p>
           <a:p>
@@ -10232,13 +9951,39 @@
               <a:buChar char="•"/>
             </a:pPr>
             <a:r>
-              <a:rPr sz="1600" b="0" i="0">
+              <a:rPr sz="1700" b="1" i="0">
                 <a:solidFill>
                   <a:srgbClr val="1B263B"/>
                 </a:solidFill>
                 <a:latin typeface="Calibri"/>
               </a:rPr>
-              <a:t>ID-based (SASRec, BERT4Rec) and text-based (TASTE, HLLM) models use every item equally → noise propagates</a:t>
+              <a:t>Two kinds of interest: </a:t>
+            </a:r>
+            <a:r>
+              <a:rPr sz="1700" b="0" i="0">
+                <a:solidFill>
+                  <a:srgbClr val="1B263B"/>
+                </a:solidFill>
+                <a:latin typeface="Calibri"/>
+              </a:rPr>
+              <a:t>stable long-term reading habits + short-term, event-driven shifts</a:t>
+            </a:r>
+          </a:p>
+          <a:p>
+            <a:pPr marL="530352" indent="-219456">
+              <a:spcAft>
+                <a:spcPts val="800"/>
+              </a:spcAft>
+              <a:buChar char="–"/>
+            </a:pPr>
+            <a:r>
+              <a:rPr sz="1500" b="0" i="0">
+                <a:solidFill>
+                  <a:srgbClr val="1B263B"/>
+                </a:solidFill>
+                <a:latin typeface="Calibri"/>
+              </a:rPr>
+              <a:t>e.g. World Cup → sports spike; pandemic → health news spike</a:t>
             </a:r>
           </a:p>
           <a:p>
@@ -10249,13 +9994,22 @@
               <a:buChar char="•"/>
             </a:pPr>
             <a:r>
-              <a:rPr sz="1600" b="0" i="0">
+              <a:rPr sz="1700" b="1" i="0">
                 <a:solidFill>
                   <a:srgbClr val="1B263B"/>
                 </a:solidFill>
                 <a:latin typeface="Calibri"/>
               </a:rPr>
-              <a:t>Existing denoising re-weights items or uses implicit contrastive learning → no explicit removal, hard to interpret</a:t>
+              <a:t>Static global graph (GCN): </a:t>
+            </a:r>
+            <a:r>
+              <a:rPr sz="1700" b="0" i="0">
+                <a:solidFill>
+                  <a:srgbClr val="1B263B"/>
+                </a:solidFill>
+                <a:latin typeface="Calibri"/>
+              </a:rPr>
+              <a:t>good collaborative signal, but outdated recommendations</a:t>
             </a:r>
           </a:p>
           <a:p>
@@ -10266,36 +10020,62 @@
               <a:buChar char="•"/>
             </a:pPr>
             <a:r>
-              <a:rPr sz="1600" b="1" i="0">
+              <a:rPr sz="1700" b="1" i="0">
                 <a:solidFill>
                   <a:srgbClr val="1B263B"/>
                 </a:solidFill>
                 <a:latin typeface="Calibri"/>
               </a:rPr>
-              <a:t>Idea: </a:t>
-            </a:r>
-            <a:r>
-              <a:rPr sz="1600" b="0" i="0">
+              <a:t>Sequential models (LSTUR, ...): </a:t>
+            </a:r>
+            <a:r>
+              <a:rPr sz="1700" b="0" i="0">
                 <a:solidFill>
                   <a:srgbClr val="1B263B"/>
                 </a:solidFill>
                 <a:latin typeface="Calibri"/>
               </a:rPr>
-              <a:t>find the semantic "shortcut" - the subset of items that agree with each other - and model the user from it</a:t>
-            </a:r>
-          </a:p>
-        </p:txBody>
-      </p:sp>
-      <p:sp>
-        <p:nvSpPr>
-          <p:cNvPr id="8" name="Rounded Rectangle 7"/>
+              <a:t>track recency, but lose stable high-order signals</a:t>
+            </a:r>
+          </a:p>
+          <a:p>
+            <a:pPr marL="256032" indent="-219456">
+              <a:spcAft>
+                <a:spcPts val="800"/>
+              </a:spcAft>
+              <a:buChar char="•"/>
+            </a:pPr>
+            <a:r>
+              <a:rPr sz="1700" b="1" i="0">
+                <a:solidFill>
+                  <a:srgbClr val="1B263B"/>
+                </a:solidFill>
+                <a:latin typeface="Calibri"/>
+              </a:rPr>
+              <a:t>Goal: </a:t>
+            </a:r>
+            <a:r>
+              <a:rPr sz="1700" b="0" i="0">
+                <a:solidFill>
+                  <a:srgbClr val="1B263B"/>
+                </a:solidFill>
+                <a:latin typeface="Calibri"/>
+              </a:rPr>
+              <a:t>keep long-term stability and stay sensitive to short-term change</a:t>
+            </a:r>
+          </a:p>
+        </p:txBody>
+      </p:sp>
+      <p:sp>
+        <p:nvSpPr>
+          <p:cNvPr id="6" name="Rounded Rectangle 5"/>
           <p:cNvSpPr/>
           <p:nvPr/>
         </p:nvSpPr>
         <p:spPr>
           <a:xfrm>
-            <a:off x="6035040" y="4160520"/>
-            <a:ext cx="5608015" cy="1097280"/>
+            <a:off x="6766560" y="1691640"/>
+            <a:ext cx="4876495" cy="1691640"/>
           </a:xfrm>
           <a:prstGeom prst="roundRect">
             <a:avLst>
@@ -10334,14 +10114,14 @@
       </p:sp>
       <p:sp>
         <p:nvSpPr>
-          <p:cNvPr id="9" name="TextBox 8"/>
+          <p:cNvPr id="7" name="TextBox 6"/>
           <p:cNvSpPr txBox="1"/>
           <p:nvPr/>
         </p:nvSpPr>
         <p:spPr>
           <a:xfrm>
-            <a:off x="6263640" y="4251960"/>
-            <a:ext cx="5150815" cy="914400"/>
+            <a:off x="6995160" y="1874520"/>
+            <a:ext cx="4419295" cy="411480"/>
           </a:xfrm>
           <a:prstGeom prst="rect">
             <a:avLst/>
@@ -10349,27 +10129,213 @@
           <a:noFill/>
         </p:spPr>
         <p:txBody>
-          <a:bodyPr wrap="square" anchor="ctr" lIns="0" rIns="0" tIns="0" bIns="0">
+          <a:bodyPr wrap="square" anchor="t" lIns="0" rIns="0" tIns="0" bIns="0">
             <a:spAutoFit/>
           </a:bodyPr>
           <a:lstStyle/>
           <a:p>
             <a:pPr algn="l"/>
             <a:r>
-              <a:rPr sz="1500" b="0" i="0">
+              <a:rPr sz="1800" b="1" i="0">
+                <a:solidFill>
+                  <a:srgbClr val="9A5B4B"/>
+                </a:solidFill>
+                <a:latin typeface="Cambria"/>
+              </a:rPr>
+              <a:t>Static models</a:t>
+            </a:r>
+          </a:p>
+        </p:txBody>
+      </p:sp>
+      <p:sp>
+        <p:nvSpPr>
+          <p:cNvPr id="8" name="TextBox 7"/>
+          <p:cNvSpPr txBox="1"/>
+          <p:nvPr/>
+        </p:nvSpPr>
+        <p:spPr>
+          <a:xfrm>
+            <a:off x="6995160" y="2331720"/>
+            <a:ext cx="4419295" cy="960120"/>
+          </a:xfrm>
+          <a:prstGeom prst="rect">
+            <a:avLst/>
+          </a:prstGeom>
+          <a:noFill/>
+        </p:spPr>
+        <p:txBody>
+          <a:bodyPr wrap="square" anchor="t" lIns="0" rIns="0" tIns="0" bIns="0">
+            <a:spAutoFit/>
+          </a:bodyPr>
+          <a:lstStyle/>
+          <a:p>
+            <a:pPr algn="l"/>
+            <a:r>
+              <a:rPr sz="1400" b="0" i="0">
                 <a:solidFill>
                   <a:srgbClr val="1B263B"/>
                 </a:solidFill>
                 <a:latin typeface="Calibri"/>
               </a:rPr>
-              <a:t>History [LEGO Iron Man, LEGO Stitch, LEGO Bugatti, Switch Mario Kart, LEGO R2-D2] → shortcut keeps the LEGO items and drops the Switch.</a:t>
-            </a:r>
+              <a:t>One graph over all time → a user's 3-month-old interest weighs as much as yesterday's. Profiles become dominated by outdated clicks.</a:t>
+            </a:r>
+          </a:p>
+        </p:txBody>
+      </p:sp>
+      <p:sp>
+        <p:nvSpPr>
+          <p:cNvPr id="9" name="Rounded Rectangle 8"/>
+          <p:cNvSpPr/>
+          <p:nvPr/>
+        </p:nvSpPr>
+        <p:spPr>
+          <a:xfrm>
+            <a:off x="6766560" y="3611880"/>
+            <a:ext cx="4876495" cy="1691640"/>
+          </a:xfrm>
+          <a:prstGeom prst="roundRect">
+            <a:avLst>
+              <a:gd name="adj" fmla="val 8000"/>
+            </a:avLst>
+          </a:prstGeom>
+          <a:solidFill>
+            <a:srgbClr val="F2F3F5"/>
+          </a:solidFill>
+          <a:ln>
+            <a:noFill/>
+          </a:ln>
+          <a:effectLst/>
+        </p:spPr>
+        <p:style>
+          <a:lnRef idx="1">
+            <a:schemeClr val="accent1"/>
+          </a:lnRef>
+          <a:fillRef idx="3">
+            <a:schemeClr val="accent1"/>
+          </a:fillRef>
+          <a:effectRef idx="2">
+            <a:schemeClr val="accent1"/>
+          </a:effectRef>
+          <a:fontRef idx="minor">
+            <a:schemeClr val="lt1"/>
+          </a:fontRef>
+        </p:style>
+        <p:txBody>
+          <a:bodyPr rtlCol="0" anchor="ctr"/>
+          <a:lstStyle/>
+          <a:p>
+            <a:pPr algn="ctr"/>
           </a:p>
         </p:txBody>
       </p:sp>
       <p:sp>
         <p:nvSpPr>
           <p:cNvPr id="10" name="TextBox 9"/>
+          <p:cNvSpPr txBox="1"/>
+          <p:nvPr/>
+        </p:nvSpPr>
+        <p:spPr>
+          <a:xfrm>
+            <a:off x="6995160" y="3794760"/>
+            <a:ext cx="4419295" cy="411480"/>
+          </a:xfrm>
+          <a:prstGeom prst="rect">
+            <a:avLst/>
+          </a:prstGeom>
+          <a:noFill/>
+        </p:spPr>
+        <p:txBody>
+          <a:bodyPr wrap="square" anchor="t" lIns="0" rIns="0" tIns="0" bIns="0">
+            <a:spAutoFit/>
+          </a:bodyPr>
+          <a:lstStyle/>
+          <a:p>
+            <a:pPr algn="l"/>
+            <a:r>
+              <a:rPr sz="1800" b="1" i="0">
+                <a:solidFill>
+                  <a:srgbClr val="9A5B4B"/>
+                </a:solidFill>
+                <a:latin typeface="Cambria"/>
+              </a:rPr>
+              <a:t>Pure sequential models</a:t>
+            </a:r>
+          </a:p>
+        </p:txBody>
+      </p:sp>
+      <p:sp>
+        <p:nvSpPr>
+          <p:cNvPr id="11" name="TextBox 10"/>
+          <p:cNvSpPr txBox="1"/>
+          <p:nvPr/>
+        </p:nvSpPr>
+        <p:spPr>
+          <a:xfrm>
+            <a:off x="6995160" y="4251960"/>
+            <a:ext cx="4419295" cy="960120"/>
+          </a:xfrm>
+          <a:prstGeom prst="rect">
+            <a:avLst/>
+          </a:prstGeom>
+          <a:noFill/>
+        </p:spPr>
+        <p:txBody>
+          <a:bodyPr wrap="square" anchor="t" lIns="0" rIns="0" tIns="0" bIns="0">
+            <a:spAutoFit/>
+          </a:bodyPr>
+          <a:lstStyle/>
+          <a:p>
+            <a:pPr algn="l"/>
+            <a:r>
+              <a:rPr sz="1400" b="0" i="0">
+                <a:solidFill>
+                  <a:srgbClr val="1B263B"/>
+                </a:solidFill>
+                <a:latin typeface="Calibri"/>
+              </a:rPr>
+              <a:t>Focus on the latest clicks → over-react to temporary trends and miss the collaborative structure of the whole graph.</a:t>
+            </a:r>
+          </a:p>
+        </p:txBody>
+      </p:sp>
+      <p:sp>
+        <p:nvSpPr>
+          <p:cNvPr id="12" name="TextBox 11"/>
+          <p:cNvSpPr txBox="1"/>
+          <p:nvPr/>
+        </p:nvSpPr>
+        <p:spPr>
+          <a:xfrm>
+            <a:off x="6766560" y="5532120"/>
+            <a:ext cx="4876495" cy="640080"/>
+          </a:xfrm>
+          <a:prstGeom prst="rect">
+            <a:avLst/>
+          </a:prstGeom>
+          <a:noFill/>
+        </p:spPr>
+        <p:txBody>
+          <a:bodyPr wrap="square" anchor="t" lIns="0" rIns="0" tIns="0" bIns="0">
+            <a:spAutoFit/>
+          </a:bodyPr>
+          <a:lstStyle/>
+          <a:p>
+            <a:pPr algn="l"/>
+            <a:r>
+              <a:rPr sz="1400" b="0" i="1">
+                <a:solidFill>
+                  <a:srgbClr val="1B263B"/>
+                </a:solidFill>
+                <a:latin typeface="Calibri"/>
+              </a:rPr>
+              <a:t>Key insight: clicks inside one period are coherent; transitions across periods show the evolution.</a:t>
+            </a:r>
+          </a:p>
+        </p:txBody>
+      </p:sp>
+      <p:sp>
+        <p:nvSpPr>
+          <p:cNvPr id="13" name="TextBox 12"/>
           <p:cNvSpPr txBox="1"/>
           <p:nvPr/>
         </p:nvSpPr>
@@ -10511,14 +10477,14 @@
                 </a:solidFill>
                 <a:latin typeface="Cambria"/>
               </a:rPr>
-              <a:t>LISRec pipeline: encode → build graph → keep the core</a:t>
+              <a:t>Framework: global graph + stage-wise subgraphs</a:t>
             </a:r>
           </a:p>
         </p:txBody>
       </p:sp>
       <p:pic>
         <p:nvPicPr>
-          <p:cNvPr id="4" name="Picture 3" descr="b_fig2_arch.png"/>
+          <p:cNvPr id="4" name="Picture 3" descr="b_fig1_framework.png"/>
           <p:cNvPicPr>
             <a:picLocks noChangeAspect="1"/>
           </p:cNvPicPr>
@@ -10532,8 +10498,8 @@
         </p:blipFill>
         <p:spPr>
           <a:xfrm>
-            <a:off x="548640" y="1731114"/>
-            <a:ext cx="7315200" cy="3898692"/>
+            <a:off x="548640" y="2015901"/>
+            <a:ext cx="7589520" cy="3329118"/>
           </a:xfrm>
           <a:prstGeom prst="rect">
             <a:avLst/>
@@ -10553,8 +10519,8 @@
         </p:nvSpPr>
         <p:spPr>
           <a:xfrm>
-            <a:off x="548640" y="5702958"/>
-            <a:ext cx="7315200" cy="274320"/>
+            <a:off x="548640" y="5418171"/>
+            <a:ext cx="7589520" cy="274320"/>
           </a:xfrm>
           <a:prstGeom prst="rect">
             <a:avLst/>
@@ -10575,74 +10541,21 @@
                 </a:solidFill>
                 <a:latin typeface="Calibri"/>
               </a:rPr>
-              <a:t>Figure 2 of Paper B: model architecture</a:t>
-            </a:r>
-          </a:p>
-        </p:txBody>
-      </p:sp>
-      <p:sp>
-        <p:nvSpPr>
-          <p:cNvPr id="6" name="Oval 5"/>
-          <p:cNvSpPr/>
-          <p:nvPr/>
-        </p:nvSpPr>
-        <p:spPr>
-          <a:xfrm>
-            <a:off x="8138160" y="1508760"/>
-            <a:ext cx="457200" cy="457200"/>
-          </a:xfrm>
-          <a:prstGeom prst="ellipse">
-            <a:avLst/>
-          </a:prstGeom>
-          <a:solidFill>
-            <a:srgbClr val="9A5B4B"/>
-          </a:solidFill>
-          <a:ln>
-            <a:noFill/>
-          </a:ln>
-          <a:effectLst/>
-        </p:spPr>
-        <p:style>
-          <a:lnRef idx="1">
-            <a:schemeClr val="accent1"/>
-          </a:lnRef>
-          <a:fillRef idx="3">
-            <a:schemeClr val="accent1"/>
-          </a:fillRef>
-          <a:effectRef idx="2">
-            <a:schemeClr val="accent1"/>
-          </a:effectRef>
-          <a:fontRef idx="minor">
-            <a:schemeClr val="lt1"/>
-          </a:fontRef>
-        </p:style>
-        <p:txBody>
-          <a:bodyPr rtlCol="0" anchor="ctr" lIns="0" rIns="0" tIns="0" bIns="0"/>
-          <a:lstStyle/>
-          <a:p>
-            <a:pPr algn="ctr"/>
-            <a:r>
-              <a:rPr sz="1600" b="1" i="0">
-                <a:solidFill>
-                  <a:srgbClr val="FFFFFF"/>
-                </a:solidFill>
-                <a:latin typeface="Cambria"/>
-              </a:rPr>
-              <a:t>1</a:t>
-            </a:r>
-          </a:p>
-        </p:txBody>
-      </p:sp>
-      <p:sp>
-        <p:nvSpPr>
-          <p:cNvPr id="7" name="TextBox 6"/>
+              <a:t>Figure 1 of Paper B: overall framework</a:t>
+            </a:r>
+          </a:p>
+        </p:txBody>
+      </p:sp>
+      <p:sp>
+        <p:nvSpPr>
+          <p:cNvPr id="6" name="TextBox 5"/>
           <p:cNvSpPr txBox="1"/>
           <p:nvPr/>
         </p:nvSpPr>
         <p:spPr>
           <a:xfrm>
-            <a:off x="8778240" y="1508760"/>
-            <a:ext cx="2864815" cy="365760"/>
+            <a:off x="8412480" y="1600200"/>
+            <a:ext cx="3230575" cy="4754880"/>
           </a:xfrm>
           <a:prstGeom prst="rect">
             <a:avLst/>
@@ -10650,308 +10563,145 @@
           <a:noFill/>
         </p:spPr>
         <p:txBody>
-          <a:bodyPr wrap="square" anchor="t" lIns="0" rIns="0" tIns="0" bIns="0">
+          <a:bodyPr wrap="square" lIns="0" rIns="0" tIns="0" bIns="0">
             <a:spAutoFit/>
           </a:bodyPr>
           <a:lstStyle/>
           <a:p>
-            <a:pPr algn="l"/>
-            <a:r>
-              <a:rPr sz="1600" b="1" i="0">
+            <a:pPr marL="256032" indent="-219456">
+              <a:spcAft>
+                <a:spcPts val="800"/>
+              </a:spcAft>
+              <a:buChar char="•"/>
+            </a:pPr>
+            <a:r>
+              <a:rPr sz="1500" b="1" i="0">
                 <a:solidFill>
                   <a:srgbClr val="1B263B"/>
                 </a:solidFill>
                 <a:latin typeface="Calibri"/>
               </a:rPr>
-              <a:t>Task-agnostic item encoder</a:t>
-            </a:r>
-          </a:p>
-        </p:txBody>
-      </p:sp>
-      <p:sp>
-        <p:nvSpPr>
-          <p:cNvPr id="8" name="TextBox 7"/>
-          <p:cNvSpPr txBox="1"/>
-          <p:nvPr/>
-        </p:nvSpPr>
-        <p:spPr>
-          <a:xfrm>
-            <a:off x="8778240" y="1892808"/>
-            <a:ext cx="2864815" cy="1097280"/>
-          </a:xfrm>
-          <a:prstGeom prst="rect">
-            <a:avLst/>
-          </a:prstGeom>
-          <a:noFill/>
-        </p:spPr>
-        <p:txBody>
-          <a:bodyPr wrap="square" anchor="t" lIns="0" rIns="0" tIns="0" bIns="0">
-            <a:spAutoFit/>
-          </a:bodyPr>
-          <a:lstStyle/>
-          <a:p>
-            <a:pPr algn="l"/>
-            <a:r>
-              <a:rPr sz="1400" b="0" i="0">
+              <a:t>GPM: </a:t>
+            </a:r>
+            <a:r>
+              <a:rPr sz="1500" b="0" i="0">
                 <a:solidFill>
                   <a:srgbClr val="1B263B"/>
                 </a:solidFill>
                 <a:latin typeface="Calibri"/>
               </a:rPr>
-              <a:t>T5 instruction-tuned on next-item prediction across datasets, using item text only (no IDs)</a:t>
-            </a:r>
-          </a:p>
-        </p:txBody>
-      </p:sp>
-      <p:sp>
-        <p:nvSpPr>
-          <p:cNvPr id="9" name="Oval 8"/>
-          <p:cNvSpPr/>
-          <p:nvPr/>
-        </p:nvSpPr>
-        <p:spPr>
-          <a:xfrm>
-            <a:off x="8138160" y="3108960"/>
-            <a:ext cx="457200" cy="457200"/>
-          </a:xfrm>
-          <a:prstGeom prst="ellipse">
-            <a:avLst/>
-          </a:prstGeom>
-          <a:solidFill>
-            <a:srgbClr val="9A5B4B"/>
-          </a:solidFill>
-          <a:ln>
-            <a:noFill/>
-          </a:ln>
-          <a:effectLst/>
-        </p:spPr>
-        <p:style>
-          <a:lnRef idx="1">
-            <a:schemeClr val="accent1"/>
-          </a:lnRef>
-          <a:fillRef idx="3">
-            <a:schemeClr val="accent1"/>
-          </a:fillRef>
-          <a:effectRef idx="2">
-            <a:schemeClr val="accent1"/>
-          </a:effectRef>
-          <a:fontRef idx="minor">
-            <a:schemeClr val="lt1"/>
-          </a:fontRef>
-        </p:style>
-        <p:txBody>
-          <a:bodyPr rtlCol="0" anchor="ctr" lIns="0" rIns="0" tIns="0" bIns="0"/>
-          <a:lstStyle/>
-          <a:p>
-            <a:pPr algn="ctr"/>
-            <a:r>
-              <a:rPr sz="1600" b="1" i="0">
-                <a:solidFill>
-                  <a:srgbClr val="FFFFFF"/>
-                </a:solidFill>
-                <a:latin typeface="Cambria"/>
-              </a:rPr>
-              <a:t>2</a:t>
-            </a:r>
-          </a:p>
-        </p:txBody>
-      </p:sp>
-      <p:sp>
-        <p:nvSpPr>
-          <p:cNvPr id="10" name="TextBox 9"/>
-          <p:cNvSpPr txBox="1"/>
-          <p:nvPr/>
-        </p:nvSpPr>
-        <p:spPr>
-          <a:xfrm>
-            <a:off x="8778240" y="3108960"/>
-            <a:ext cx="2864815" cy="365760"/>
-          </a:xfrm>
-          <a:prstGeom prst="rect">
-            <a:avLst/>
-          </a:prstGeom>
-          <a:noFill/>
-        </p:spPr>
-        <p:txBody>
-          <a:bodyPr wrap="square" anchor="t" lIns="0" rIns="0" tIns="0" bIns="0">
-            <a:spAutoFit/>
-          </a:bodyPr>
-          <a:lstStyle/>
-          <a:p>
-            <a:pPr algn="l"/>
-            <a:r>
-              <a:rPr sz="1600" b="1" i="0">
+              <a:t>LightGCN on the full user–news graph → long-term embeddings e_g</a:t>
+            </a:r>
+          </a:p>
+          <a:p>
+            <a:pPr marL="256032" indent="-219456">
+              <a:spcAft>
+                <a:spcPts val="800"/>
+              </a:spcAft>
+              <a:buChar char="•"/>
+            </a:pPr>
+            <a:r>
+              <a:rPr sz="1500" b="1" i="0">
                 <a:solidFill>
                   <a:srgbClr val="1B263B"/>
                 </a:solidFill>
                 <a:latin typeface="Calibri"/>
               </a:rPr>
-              <a:t>Personal item graph</a:t>
-            </a:r>
-          </a:p>
-        </p:txBody>
-      </p:sp>
-      <p:sp>
-        <p:nvSpPr>
-          <p:cNvPr id="11" name="TextBox 10"/>
-          <p:cNvSpPr txBox="1"/>
-          <p:nvPr/>
-        </p:nvSpPr>
-        <p:spPr>
-          <a:xfrm>
-            <a:off x="8778240" y="3493008"/>
-            <a:ext cx="2864815" cy="1097280"/>
-          </a:xfrm>
-          <a:prstGeom prst="rect">
-            <a:avLst/>
-          </a:prstGeom>
-          <a:noFill/>
-        </p:spPr>
-        <p:txBody>
-          <a:bodyPr wrap="square" anchor="t" lIns="0" rIns="0" tIns="0" bIns="0">
-            <a:spAutoFit/>
-          </a:bodyPr>
-          <a:lstStyle/>
-          <a:p>
-            <a:pPr algn="l"/>
-            <a:r>
-              <a:rPr sz="1400" b="0" i="0">
+              <a:t>Temporal subgraphs: </a:t>
+            </a:r>
+            <a:r>
+              <a:rPr sz="1500" b="0" i="0">
                 <a:solidFill>
                   <a:srgbClr val="1B263B"/>
                 </a:solidFill>
                 <a:latin typeface="Calibri"/>
               </a:rPr>
-              <a:t>Edge between two clicked items if cos(vi, vj) ≥ τ (τ = 0.7)</a:t>
-            </a:r>
-          </a:p>
-        </p:txBody>
-      </p:sp>
-      <p:sp>
-        <p:nvSpPr>
-          <p:cNvPr id="12" name="Oval 11"/>
-          <p:cNvSpPr/>
-          <p:nvPr/>
-        </p:nvSpPr>
-        <p:spPr>
-          <a:xfrm>
-            <a:off x="8138160" y="4709160"/>
-            <a:ext cx="457200" cy="457200"/>
-          </a:xfrm>
-          <a:prstGeom prst="ellipse">
-            <a:avLst/>
-          </a:prstGeom>
-          <a:solidFill>
-            <a:srgbClr val="9A5B4B"/>
-          </a:solidFill>
-          <a:ln>
-            <a:noFill/>
-          </a:ln>
-          <a:effectLst/>
-        </p:spPr>
-        <p:style>
-          <a:lnRef idx="1">
-            <a:schemeClr val="accent1"/>
-          </a:lnRef>
-          <a:fillRef idx="3">
-            <a:schemeClr val="accent1"/>
-          </a:fillRef>
-          <a:effectRef idx="2">
-            <a:schemeClr val="accent1"/>
-          </a:effectRef>
-          <a:fontRef idx="minor">
-            <a:schemeClr val="lt1"/>
-          </a:fontRef>
-        </p:style>
-        <p:txBody>
-          <a:bodyPr rtlCol="0" anchor="ctr" lIns="0" rIns="0" tIns="0" bIns="0"/>
-          <a:lstStyle/>
-          <a:p>
-            <a:pPr algn="ctr"/>
-            <a:r>
-              <a:rPr sz="1600" b="1" i="0">
-                <a:solidFill>
-                  <a:srgbClr val="FFFFFF"/>
-                </a:solidFill>
-                <a:latin typeface="Cambria"/>
-              </a:rPr>
-              <a:t>3</a:t>
-            </a:r>
-          </a:p>
-        </p:txBody>
-      </p:sp>
-      <p:sp>
-        <p:nvSpPr>
-          <p:cNvPr id="13" name="TextBox 12"/>
-          <p:cNvSpPr txBox="1"/>
-          <p:nvPr/>
-        </p:nvSpPr>
-        <p:spPr>
-          <a:xfrm>
-            <a:off x="8778240" y="4709160"/>
-            <a:ext cx="2864815" cy="365760"/>
-          </a:xfrm>
-          <a:prstGeom prst="rect">
-            <a:avLst/>
-          </a:prstGeom>
-          <a:noFill/>
-        </p:spPr>
-        <p:txBody>
-          <a:bodyPr wrap="square" anchor="t" lIns="0" rIns="0" tIns="0" bIns="0">
-            <a:spAutoFit/>
-          </a:bodyPr>
-          <a:lstStyle/>
-          <a:p>
-            <a:pPr algn="l"/>
-            <a:r>
-              <a:rPr sz="1600" b="1" i="0">
+              <a:t>split clicks into T windows (e.g. 2 weeks), one subgraph G_t each</a:t>
+            </a:r>
+          </a:p>
+          <a:p>
+            <a:pPr marL="256032" indent="-219456">
+              <a:spcAft>
+                <a:spcPts val="800"/>
+              </a:spcAft>
+              <a:buChar char="•"/>
+            </a:pPr>
+            <a:r>
+              <a:rPr sz="1500" b="1" i="0">
                 <a:solidFill>
                   <a:srgbClr val="1B263B"/>
                 </a:solidFill>
                 <a:latin typeface="Calibri"/>
               </a:rPr>
-              <a:t>Shortcut = largest component</a:t>
-            </a:r>
-          </a:p>
-        </p:txBody>
-      </p:sp>
-      <p:sp>
-        <p:nvSpPr>
-          <p:cNvPr id="14" name="TextBox 13"/>
-          <p:cNvSpPr txBox="1"/>
-          <p:nvPr/>
-        </p:nvSpPr>
-        <p:spPr>
-          <a:xfrm>
-            <a:off x="8778240" y="5093208"/>
-            <a:ext cx="2864815" cy="1097280"/>
-          </a:xfrm>
-          <a:prstGeom prst="rect">
-            <a:avLst/>
-          </a:prstGeom>
-          <a:noFill/>
-        </p:spPr>
-        <p:txBody>
-          <a:bodyPr wrap="square" anchor="t" lIns="0" rIns="0" tIns="0" bIns="0">
-            <a:spAutoFit/>
-          </a:bodyPr>
-          <a:lstStyle/>
-          <a:p>
-            <a:pPr algn="l"/>
-            <a:r>
-              <a:rPr sz="1400" b="0" i="0">
+              <a:t>Short-term branch: </a:t>
+            </a:r>
+            <a:r>
+              <a:rPr sz="1500" b="0" i="0">
                 <a:solidFill>
                   <a:srgbClr val="1B263B"/>
                 </a:solidFill>
                 <a:latin typeface="Calibri"/>
               </a:rPr>
-              <a:t>Its items become the denoised history fed to the recommender (TASTE / BERT4Rec)</a:t>
-            </a:r>
-          </a:p>
-        </p:txBody>
-      </p:sp>
-      <p:sp>
-        <p:nvSpPr>
-          <p:cNvPr id="15" name="TextBox 14"/>
+              <a:t>GCN on each G_t (initialised by e_g) + LSTM across stages</a:t>
+            </a:r>
+          </a:p>
+          <a:p>
+            <a:pPr marL="256032" indent="-219456">
+              <a:spcAft>
+                <a:spcPts val="800"/>
+              </a:spcAft>
+              <a:buChar char="•"/>
+            </a:pPr>
+            <a:r>
+              <a:rPr sz="1500" b="1" i="0">
+                <a:solidFill>
+                  <a:srgbClr val="1B263B"/>
+                </a:solidFill>
+                <a:latin typeface="Calibri"/>
+              </a:rPr>
+              <a:t>Long-range branch: </a:t>
+            </a:r>
+            <a:r>
+              <a:rPr sz="1500" b="0" i="0">
+                <a:solidFill>
+                  <a:srgbClr val="1B263B"/>
+                </a:solidFill>
+                <a:latin typeface="Calibri"/>
+              </a:rPr>
+              <a:t>self-attention over all clicks up to stage t + position embedding</a:t>
+            </a:r>
+          </a:p>
+          <a:p>
+            <a:pPr marL="256032" indent="-219456">
+              <a:spcAft>
+                <a:spcPts val="800"/>
+              </a:spcAft>
+              <a:buChar char="•"/>
+            </a:pPr>
+            <a:r>
+              <a:rPr sz="1500" b="1" i="0">
+                <a:solidFill>
+                  <a:srgbClr val="1B263B"/>
+                </a:solidFill>
+                <a:latin typeface="Calibri"/>
+              </a:rPr>
+              <a:t>Fusion: </a:t>
+            </a:r>
+            <a:r>
+              <a:rPr sz="1500" b="0" i="0">
+                <a:solidFill>
+                  <a:srgbClr val="1B263B"/>
+                </a:solidFill>
+                <a:latin typeface="Calibri"/>
+              </a:rPr>
+              <a:t>user = short-term + long-range + global; score = σ(u·i)</a:t>
+            </a:r>
+          </a:p>
+        </p:txBody>
+      </p:sp>
+      <p:sp>
+        <p:nvSpPr>
+          <p:cNvPr id="7" name="TextBox 6"/>
           <p:cNvSpPr txBox="1"/>
           <p:nvPr/>
         </p:nvSpPr>
@@ -11093,40 +10843,57 @@
                 </a:solidFill>
                 <a:latin typeface="Cambria"/>
               </a:rPr>
-              <a:t>Case study: the perfume that does not belong</a:t>
-            </a:r>
-          </a:p>
-        </p:txBody>
-      </p:sp>
-      <p:pic>
-        <p:nvPicPr>
-          <p:cNvPr id="4" name="Picture 3" descr="b_tab5_case.png"/>
-          <p:cNvPicPr>
-            <a:picLocks noChangeAspect="1"/>
-          </p:cNvPicPr>
-          <p:nvPr/>
-        </p:nvPicPr>
-        <p:blipFill>
-          <a:blip r:embed="rId2"/>
-          <a:stretch>
-            <a:fillRect/>
-          </a:stretch>
-        </p:blipFill>
-        <p:spPr>
-          <a:xfrm>
-            <a:off x="548640" y="1750664"/>
-            <a:ext cx="7680960" cy="3219512"/>
-          </a:xfrm>
-          <a:prstGeom prst="rect">
-            <a:avLst/>
-          </a:prstGeom>
-          <a:ln w="9525">
-            <a:solidFill>
-              <a:srgbClr val="D5DAE1"/>
-            </a:solidFill>
+              <a:t>Training: one prediction loss, two regularisers</a:t>
+            </a:r>
+          </a:p>
+        </p:txBody>
+      </p:sp>
+      <p:sp>
+        <p:nvSpPr>
+          <p:cNvPr id="4" name="Rounded Rectangle 3"/>
+          <p:cNvSpPr/>
+          <p:nvPr/>
+        </p:nvSpPr>
+        <p:spPr>
+          <a:xfrm>
+            <a:off x="548640" y="1600200"/>
+            <a:ext cx="3515258" cy="1874519"/>
+          </a:xfrm>
+          <a:prstGeom prst="roundRect">
+            <a:avLst>
+              <a:gd name="adj" fmla="val 8000"/>
+            </a:avLst>
+          </a:prstGeom>
+          <a:solidFill>
+            <a:srgbClr val="F2F3F5"/>
+          </a:solidFill>
+          <a:ln>
+            <a:noFill/>
           </a:ln>
-        </p:spPr>
-      </p:pic>
+          <a:effectLst/>
+        </p:spPr>
+        <p:style>
+          <a:lnRef idx="1">
+            <a:schemeClr val="accent1"/>
+          </a:lnRef>
+          <a:fillRef idx="3">
+            <a:schemeClr val="accent1"/>
+          </a:fillRef>
+          <a:effectRef idx="2">
+            <a:schemeClr val="accent1"/>
+          </a:effectRef>
+          <a:fontRef idx="minor">
+            <a:schemeClr val="lt1"/>
+          </a:fontRef>
+        </p:style>
+        <p:txBody>
+          <a:bodyPr rtlCol="0" anchor="ctr"/>
+          <a:lstStyle/>
+          <a:p>
+            <a:pPr algn="ctr"/>
+          </a:p>
+        </p:txBody>
+      </p:sp>
       <p:sp>
         <p:nvSpPr>
           <p:cNvPr id="5" name="TextBox 4"/>
@@ -11135,8 +10902,8 @@
         </p:nvSpPr>
         <p:spPr>
           <a:xfrm>
-            <a:off x="548640" y="5043328"/>
-            <a:ext cx="7680960" cy="274320"/>
+            <a:off x="777240" y="1783080"/>
+            <a:ext cx="3058058" cy="411480"/>
           </a:xfrm>
           <a:prstGeom prst="rect">
             <a:avLst/>
@@ -11149,15 +10916,15 @@
           </a:bodyPr>
           <a:lstStyle/>
           <a:p>
-            <a:pPr algn="ctr"/>
-            <a:r>
-              <a:rPr sz="1100" b="0" i="1">
-                <a:solidFill>
-                  <a:srgbClr val="5B677A"/>
-                </a:solidFill>
-                <a:latin typeface="Calibri"/>
-              </a:rPr>
-              <a:t>Table 5 of Paper B: Amazon Beauty case</a:t>
+            <a:pPr algn="l"/>
+            <a:r>
+              <a:rPr sz="1800" b="1" i="0">
+                <a:solidFill>
+                  <a:srgbClr val="9A5B4B"/>
+                </a:solidFill>
+                <a:latin typeface="Cambria"/>
+              </a:rPr>
+              <a:t>Prediction  (λt = 0.1)</a:t>
             </a:r>
           </a:p>
         </p:txBody>
@@ -11170,8 +10937,310 @@
         </p:nvSpPr>
         <p:spPr>
           <a:xfrm>
-            <a:off x="8503919" y="1600200"/>
-            <a:ext cx="3139136" cy="4206240"/>
+            <a:off x="777240" y="2240280"/>
+            <a:ext cx="3058058" cy="1142999"/>
+          </a:xfrm>
+          <a:prstGeom prst="rect">
+            <a:avLst/>
+          </a:prstGeom>
+          <a:noFill/>
+        </p:spPr>
+        <p:txBody>
+          <a:bodyPr wrap="square" anchor="t" lIns="0" rIns="0" tIns="0" bIns="0">
+            <a:spAutoFit/>
+          </a:bodyPr>
+          <a:lstStyle/>
+          <a:p>
+            <a:pPr algn="l"/>
+            <a:r>
+              <a:rPr sz="1500" b="0" i="0">
+                <a:solidFill>
+                  <a:srgbClr val="1B263B"/>
+                </a:solidFill>
+                <a:latin typeface="Calibri"/>
+              </a:rPr>
+              <a:t>Binary cross-entropy on clicks inside each time segment, with 4 sampled negatives per positive click.</a:t>
+            </a:r>
+          </a:p>
+        </p:txBody>
+      </p:sp>
+      <p:sp>
+        <p:nvSpPr>
+          <p:cNvPr id="7" name="Rounded Rectangle 6"/>
+          <p:cNvSpPr/>
+          <p:nvPr/>
+        </p:nvSpPr>
+        <p:spPr>
+          <a:xfrm>
+            <a:off x="4338218" y="1600200"/>
+            <a:ext cx="3515258" cy="1874519"/>
+          </a:xfrm>
+          <a:prstGeom prst="roundRect">
+            <a:avLst>
+              <a:gd name="adj" fmla="val 8000"/>
+            </a:avLst>
+          </a:prstGeom>
+          <a:solidFill>
+            <a:srgbClr val="F2F3F5"/>
+          </a:solidFill>
+          <a:ln>
+            <a:noFill/>
+          </a:ln>
+          <a:effectLst/>
+        </p:spPr>
+        <p:style>
+          <a:lnRef idx="1">
+            <a:schemeClr val="accent1"/>
+          </a:lnRef>
+          <a:fillRef idx="3">
+            <a:schemeClr val="accent1"/>
+          </a:fillRef>
+          <a:effectRef idx="2">
+            <a:schemeClr val="accent1"/>
+          </a:effectRef>
+          <a:fontRef idx="minor">
+            <a:schemeClr val="lt1"/>
+          </a:fontRef>
+        </p:style>
+        <p:txBody>
+          <a:bodyPr rtlCol="0" anchor="ctr"/>
+          <a:lstStyle/>
+          <a:p>
+            <a:pPr algn="ctr"/>
+          </a:p>
+        </p:txBody>
+      </p:sp>
+      <p:sp>
+        <p:nvSpPr>
+          <p:cNvPr id="8" name="TextBox 7"/>
+          <p:cNvSpPr txBox="1"/>
+          <p:nvPr/>
+        </p:nvSpPr>
+        <p:spPr>
+          <a:xfrm>
+            <a:off x="4566818" y="1783080"/>
+            <a:ext cx="3058058" cy="411480"/>
+          </a:xfrm>
+          <a:prstGeom prst="rect">
+            <a:avLst/>
+          </a:prstGeom>
+          <a:noFill/>
+        </p:spPr>
+        <p:txBody>
+          <a:bodyPr wrap="square" anchor="t" lIns="0" rIns="0" tIns="0" bIns="0">
+            <a:spAutoFit/>
+          </a:bodyPr>
+          <a:lstStyle/>
+          <a:p>
+            <a:pPr algn="l"/>
+            <a:r>
+              <a:rPr sz="1800" b="1" i="0">
+                <a:solidFill>
+                  <a:srgbClr val="9A5B4B"/>
+                </a:solidFill>
+                <a:latin typeface="Cambria"/>
+              </a:rPr>
+              <a:t>Consistency  (λcl = 0.01)</a:t>
+            </a:r>
+          </a:p>
+        </p:txBody>
+      </p:sp>
+      <p:sp>
+        <p:nvSpPr>
+          <p:cNvPr id="9" name="TextBox 8"/>
+          <p:cNvSpPr txBox="1"/>
+          <p:nvPr/>
+        </p:nvSpPr>
+        <p:spPr>
+          <a:xfrm>
+            <a:off x="4566818" y="2240280"/>
+            <a:ext cx="3058058" cy="1142999"/>
+          </a:xfrm>
+          <a:prstGeom prst="rect">
+            <a:avLst/>
+          </a:prstGeom>
+          <a:noFill/>
+        </p:spPr>
+        <p:txBody>
+          <a:bodyPr wrap="square" anchor="t" lIns="0" rIns="0" tIns="0" bIns="0">
+            <a:spAutoFit/>
+          </a:bodyPr>
+          <a:lstStyle/>
+          <a:p>
+            <a:pPr algn="l"/>
+            <a:r>
+              <a:rPr sz="1500" b="0" i="0">
+                <a:solidFill>
+                  <a:srgbClr val="1B263B"/>
+                </a:solidFill>
+                <a:latin typeface="Calibri"/>
+              </a:rPr>
+              <a:t>Contrastive (InfoNCE, τ = 0.1): a user's stage embedding should stay close to their own global embedding and far from other users'.</a:t>
+            </a:r>
+          </a:p>
+        </p:txBody>
+      </p:sp>
+      <p:sp>
+        <p:nvSpPr>
+          <p:cNvPr id="10" name="Rounded Rectangle 9"/>
+          <p:cNvSpPr/>
+          <p:nvPr/>
+        </p:nvSpPr>
+        <p:spPr>
+          <a:xfrm>
+            <a:off x="8127796" y="1600200"/>
+            <a:ext cx="3515258" cy="1874519"/>
+          </a:xfrm>
+          <a:prstGeom prst="roundRect">
+            <a:avLst>
+              <a:gd name="adj" fmla="val 8000"/>
+            </a:avLst>
+          </a:prstGeom>
+          <a:solidFill>
+            <a:srgbClr val="F2F3F5"/>
+          </a:solidFill>
+          <a:ln>
+            <a:noFill/>
+          </a:ln>
+          <a:effectLst/>
+        </p:spPr>
+        <p:style>
+          <a:lnRef idx="1">
+            <a:schemeClr val="accent1"/>
+          </a:lnRef>
+          <a:fillRef idx="3">
+            <a:schemeClr val="accent1"/>
+          </a:fillRef>
+          <a:effectRef idx="2">
+            <a:schemeClr val="accent1"/>
+          </a:effectRef>
+          <a:fontRef idx="minor">
+            <a:schemeClr val="lt1"/>
+          </a:fontRef>
+        </p:style>
+        <p:txBody>
+          <a:bodyPr rtlCol="0" anchor="ctr"/>
+          <a:lstStyle/>
+          <a:p>
+            <a:pPr algn="ctr"/>
+          </a:p>
+        </p:txBody>
+      </p:sp>
+      <p:sp>
+        <p:nvSpPr>
+          <p:cNvPr id="11" name="TextBox 10"/>
+          <p:cNvSpPr txBox="1"/>
+          <p:nvPr/>
+        </p:nvSpPr>
+        <p:spPr>
+          <a:xfrm>
+            <a:off x="8356396" y="1783080"/>
+            <a:ext cx="3058058" cy="411480"/>
+          </a:xfrm>
+          <a:prstGeom prst="rect">
+            <a:avLst/>
+          </a:prstGeom>
+          <a:noFill/>
+        </p:spPr>
+        <p:txBody>
+          <a:bodyPr wrap="square" anchor="t" lIns="0" rIns="0" tIns="0" bIns="0">
+            <a:spAutoFit/>
+          </a:bodyPr>
+          <a:lstStyle/>
+          <a:p>
+            <a:pPr algn="l"/>
+            <a:r>
+              <a:rPr sz="1800" b="1" i="0">
+                <a:solidFill>
+                  <a:srgbClr val="9A5B4B"/>
+                </a:solidFill>
+                <a:latin typeface="Cambria"/>
+              </a:rPr>
+              <a:t>Smoothness  (λsl = 0.01)</a:t>
+            </a:r>
+          </a:p>
+        </p:txBody>
+      </p:sp>
+      <p:sp>
+        <p:nvSpPr>
+          <p:cNvPr id="12" name="TextBox 11"/>
+          <p:cNvSpPr txBox="1"/>
+          <p:nvPr/>
+        </p:nvSpPr>
+        <p:spPr>
+          <a:xfrm>
+            <a:off x="8356396" y="2240280"/>
+            <a:ext cx="3058058" cy="1142999"/>
+          </a:xfrm>
+          <a:prstGeom prst="rect">
+            <a:avLst/>
+          </a:prstGeom>
+          <a:noFill/>
+        </p:spPr>
+        <p:txBody>
+          <a:bodyPr wrap="square" anchor="t" lIns="0" rIns="0" tIns="0" bIns="0">
+            <a:spAutoFit/>
+          </a:bodyPr>
+          <a:lstStyle/>
+          <a:p>
+            <a:pPr algn="l"/>
+            <a:r>
+              <a:rPr sz="1500" b="0" i="0">
+                <a:solidFill>
+                  <a:srgbClr val="1B263B"/>
+                </a:solidFill>
+                <a:latin typeface="Calibri"/>
+              </a:rPr>
+              <a:t>‖e_u^t − e_u^(t−1)‖² keeps adjacent stages close: interests drift gradually, not abruptly.</a:t>
+            </a:r>
+          </a:p>
+        </p:txBody>
+      </p:sp>
+      <p:sp>
+        <p:nvSpPr>
+          <p:cNvPr id="13" name="TextBox 12"/>
+          <p:cNvSpPr txBox="1"/>
+          <p:nvPr/>
+        </p:nvSpPr>
+        <p:spPr>
+          <a:xfrm>
+            <a:off x="548640" y="3886200"/>
+            <a:ext cx="11094415" cy="548640"/>
+          </a:xfrm>
+          <a:prstGeom prst="rect">
+            <a:avLst/>
+          </a:prstGeom>
+          <a:noFill/>
+        </p:spPr>
+        <p:txBody>
+          <a:bodyPr wrap="square" anchor="t" lIns="0" rIns="0" tIns="0" bIns="0">
+            <a:spAutoFit/>
+          </a:bodyPr>
+          <a:lstStyle/>
+          <a:p>
+            <a:pPr algn="ctr"/>
+            <a:r>
+              <a:rPr sz="2400" b="1" i="0">
+                <a:solidFill>
+                  <a:srgbClr val="1B263B"/>
+                </a:solidFill>
+                <a:latin typeface="Cambria"/>
+              </a:rPr>
+              <a:t>L  =  Σt λt·Lt  +  λcl·Lcl  +  λsl·Lsl  +  β‖Θ‖²</a:t>
+            </a:r>
+          </a:p>
+        </p:txBody>
+      </p:sp>
+      <p:sp>
+        <p:nvSpPr>
+          <p:cNvPr id="14" name="TextBox 13"/>
+          <p:cNvSpPr txBox="1"/>
+          <p:nvPr/>
+        </p:nvSpPr>
+        <p:spPr>
+          <a:xfrm>
+            <a:off x="548640" y="4800600"/>
+            <a:ext cx="11094415" cy="1463040"/>
           </a:xfrm>
           <a:prstGeom prst="rect">
             <a:avLst/>
@@ -11191,13 +11260,22 @@
               <a:buChar char="•"/>
             </a:pPr>
             <a:r>
+              <a:rPr sz="1500" b="1" i="0">
+                <a:solidFill>
+                  <a:srgbClr val="1B263B"/>
+                </a:solidFill>
+                <a:latin typeface="Calibri"/>
+              </a:rPr>
+              <a:t>Datasets: </a:t>
+            </a:r>
+            <a:r>
               <a:rPr sz="1500" b="0" i="0">
                 <a:solidFill>
                   <a:srgbClr val="1B263B"/>
                 </a:solidFill>
                 <a:latin typeface="Calibri"/>
               </a:rPr>
-              <a:t>n1, n2, n4 are moisturisers; pairwise similarity ≈ 0.44–0.46</a:t>
+              <a:t>Adressa-large (3.6M users, 35M clicks, 3 months) and MIND-large (1M users, 24M clicks, 6 weeks)</a:t>
             </a:r>
           </a:p>
           <a:p>
@@ -11214,7 +11292,7 @@
                 </a:solidFill>
                 <a:latin typeface="Calibri"/>
               </a:rPr>
-              <a:t>n3 is a perfume: </a:t>
+              <a:t>Metrics: </a:t>
             </a:r>
             <a:r>
               <a:rPr sz="1500" b="0" i="0">
@@ -11223,92 +11301,14 @@
                 </a:solidFill>
                 <a:latin typeface="Calibri"/>
               </a:rPr>
-              <a:t>similarity to the rest only 0.20–0.25</a:t>
-            </a:r>
-          </a:p>
-          <a:p>
-            <a:pPr marL="256032" indent="-219456">
-              <a:spcAft>
-                <a:spcPts val="800"/>
-              </a:spcAft>
-              <a:buChar char="•"/>
-            </a:pPr>
-            <a:r>
-              <a:rPr sz="1500" b="0" i="0">
-                <a:solidFill>
-                  <a:srgbClr val="1B263B"/>
-                </a:solidFill>
-                <a:latin typeface="Calibri"/>
-              </a:rPr>
-              <a:t>No edge reaches n3 → shortcut = {1, 2, 4}</a:t>
-            </a:r>
-          </a:p>
-          <a:p>
-            <a:pPr marL="256032" indent="-219456">
-              <a:spcAft>
-                <a:spcPts val="800"/>
-              </a:spcAft>
-              <a:buChar char="•"/>
-            </a:pPr>
-            <a:r>
-              <a:rPr sz="1500" b="1" i="0">
-                <a:solidFill>
-                  <a:srgbClr val="1B263B"/>
-                </a:solidFill>
-                <a:latin typeface="Calibri"/>
-              </a:rPr>
-              <a:t>Yelp case: </a:t>
-            </a:r>
-            <a:r>
-              <a:rPr sz="1500" b="0" i="0">
-                <a:solidFill>
-                  <a:srgbClr val="1B263B"/>
-                </a:solidFill>
-                <a:latin typeface="Calibri"/>
-              </a:rPr>
-              <a:t>a vet clinic among bars &amp; restaurants is dropped the same way</a:t>
-            </a:r>
-          </a:p>
-        </p:txBody>
-      </p:sp>
-      <p:sp>
-        <p:nvSpPr>
-          <p:cNvPr id="7" name="TextBox 6"/>
-          <p:cNvSpPr txBox="1"/>
-          <p:nvPr/>
-        </p:nvSpPr>
-        <p:spPr>
-          <a:xfrm>
-            <a:off x="548640" y="5760720"/>
-            <a:ext cx="11094415" cy="457200"/>
-          </a:xfrm>
-          <a:prstGeom prst="rect">
-            <a:avLst/>
-          </a:prstGeom>
-          <a:noFill/>
-        </p:spPr>
-        <p:txBody>
-          <a:bodyPr wrap="square" anchor="t" lIns="0" rIns="0" tIns="0" bIns="0">
-            <a:spAutoFit/>
-          </a:bodyPr>
-          <a:lstStyle/>
-          <a:p>
-            <a:pPr algn="l"/>
-            <a:r>
-              <a:rPr sz="1500" b="0" i="1">
-                <a:solidFill>
-                  <a:srgbClr val="1B263B"/>
-                </a:solidFill>
-                <a:latin typeface="Calibri"/>
-              </a:rPr>
-              <a:t>Explicit, inspectable denoising: you can see exactly which clicks were removed and why.</a:t>
-            </a:r>
-          </a:p>
-        </p:txBody>
-      </p:sp>
-      <p:sp>
-        <p:nvSpPr>
-          <p:cNvPr id="8" name="TextBox 7"/>
+              <a:t>AUC, MRR, nDCG@5/10 against 7 baselines (NRMS, NAML, NPA, LightGCN, CNE-SUE, TCCM, CROWN)</a:t>
+            </a:r>
+          </a:p>
+        </p:txBody>
+      </p:sp>
+      <p:sp>
+        <p:nvSpPr>
+          <p:cNvPr id="15" name="TextBox 14"/>
           <p:cNvSpPr txBox="1"/>
           <p:nvPr/>
         </p:nvSpPr>

</xml_diff>